<commit_message>
Ajout de l'url de l'atelier
</commit_message>
<xml_diff>
--- a/Présentation.pptx
+++ b/Présentation.pptx
@@ -109,6 +109,11 @@
       </a:defRPr>
     </a:lvl9pPr>
   </p:defaultTextStyle>
+  <p:extLst>
+    <p:ext uri="{EFAFB233-063F-42B5-8137-9DF3F51BA10A}">
+      <p15:sldGuideLst xmlns:p15="http://schemas.microsoft.com/office/powerpoint/2012/main"/>
+    </p:ext>
+  </p:extLst>
 </p:presentation>
 </file>
 
@@ -3713,15 +3718,66 @@
           <a:bodyPr/>
           <a:lstStyle/>
           <a:p>
-            <a:r>
-              <a:rPr lang="fr-FR" dirty="0"/>
-              <a:t>Mettre le lien du </a:t>
-            </a:r>
-            <a:r>
-              <a:rPr lang="fr-FR" dirty="0" err="1"/>
-              <a:t>claat</a:t>
-            </a:r>
-            <a:endParaRPr lang="fr-FR" dirty="0"/>
+            <a:pPr marL="0" indent="0">
+              <a:buNone/>
+            </a:pPr>
+            <a:r>
+              <a:rPr lang="fr-FR" b="0" u="sng" dirty="0">
+                <a:solidFill>
+                  <a:schemeClr val="accent1">
+                    <a:lumMod val="75000"/>
+                  </a:schemeClr>
+                </a:solidFill>
+                <a:effectLst/>
+                <a:latin typeface="JetBrains Mono"/>
+              </a:rPr>
+              <a:t>https://</a:t>
+            </a:r>
+            <a:r>
+              <a:rPr lang="fr-FR" b="0" u="sng" dirty="0" err="1">
+                <a:solidFill>
+                  <a:schemeClr val="accent1">
+                    <a:lumMod val="75000"/>
+                  </a:schemeClr>
+                </a:solidFill>
+                <a:effectLst/>
+                <a:latin typeface="JetBrains Mono"/>
+              </a:rPr>
+              <a:t>yatho.github.io</a:t>
+            </a:r>
+            <a:r>
+              <a:rPr lang="fr-FR" b="0" u="sng" dirty="0">
+                <a:solidFill>
+                  <a:schemeClr val="accent1">
+                    <a:lumMod val="75000"/>
+                  </a:schemeClr>
+                </a:solidFill>
+                <a:effectLst/>
+                <a:latin typeface="JetBrains Mono"/>
+              </a:rPr>
+              <a:t>/atelier-Angular17/atelier-angular-17/</a:t>
+            </a:r>
+            <a:endParaRPr lang="fr-FR" b="0" dirty="0">
+              <a:solidFill>
+                <a:schemeClr val="accent1">
+                  <a:lumMod val="75000"/>
+                </a:schemeClr>
+              </a:solidFill>
+              <a:effectLst/>
+              <a:latin typeface="JetBrains Mono"/>
+            </a:endParaRPr>
+          </a:p>
+          <a:p>
+            <a:pPr marL="0" indent="0">
+              <a:buNone/>
+            </a:pPr>
+            <a:endParaRPr lang="fr-FR" dirty="0">
+              <a:solidFill>
+                <a:schemeClr val="accent1">
+                  <a:lumMod val="75000"/>
+                </a:schemeClr>
+              </a:solidFill>
+            </a:endParaRPr>
           </a:p>
         </p:txBody>
       </p:sp>

</xml_diff>

<commit_message>
Mise à jour du powerpoint
</commit_message>
<xml_diff>
--- a/Présentation.pptx
+++ b/Présentation.pptx
@@ -9,8 +9,19 @@
     <p:sldId id="257" r:id="rId3"/>
     <p:sldId id="258" r:id="rId4"/>
     <p:sldId id="259" r:id="rId5"/>
-    <p:sldId id="260" r:id="rId6"/>
-    <p:sldId id="261" r:id="rId7"/>
+    <p:sldId id="264" r:id="rId6"/>
+    <p:sldId id="274" r:id="rId7"/>
+    <p:sldId id="266" r:id="rId8"/>
+    <p:sldId id="263" r:id="rId9"/>
+    <p:sldId id="267" r:id="rId10"/>
+    <p:sldId id="265" r:id="rId11"/>
+    <p:sldId id="268" r:id="rId12"/>
+    <p:sldId id="269" r:id="rId13"/>
+    <p:sldId id="270" r:id="rId14"/>
+    <p:sldId id="271" r:id="rId15"/>
+    <p:sldId id="273" r:id="rId16"/>
+    <p:sldId id="272" r:id="rId17"/>
+    <p:sldId id="261" r:id="rId18"/>
   </p:sldIdLst>
   <p:sldSz cx="12192000" cy="6858000"/>
   <p:notesSz cx="6858000" cy="9144000"/>
@@ -264,7 +275,7 @@
           <a:p>
             <a:fld id="{B31D952E-9AEA-B24E-B6B1-F2B5D1DED824}" type="datetimeFigureOut">
               <a:rPr lang="fr-FR" smtClean="0"/>
-              <a:t>08/12/2023</a:t>
+              <a:t>21/12/2023</a:t>
             </a:fld>
             <a:endParaRPr lang="fr-FR"/>
           </a:p>
@@ -462,7 +473,7 @@
           <a:p>
             <a:fld id="{B31D952E-9AEA-B24E-B6B1-F2B5D1DED824}" type="datetimeFigureOut">
               <a:rPr lang="fr-FR" smtClean="0"/>
-              <a:t>08/12/2023</a:t>
+              <a:t>21/12/2023</a:t>
             </a:fld>
             <a:endParaRPr lang="fr-FR"/>
           </a:p>
@@ -670,7 +681,7 @@
           <a:p>
             <a:fld id="{B31D952E-9AEA-B24E-B6B1-F2B5D1DED824}" type="datetimeFigureOut">
               <a:rPr lang="fr-FR" smtClean="0"/>
-              <a:t>08/12/2023</a:t>
+              <a:t>21/12/2023</a:t>
             </a:fld>
             <a:endParaRPr lang="fr-FR"/>
           </a:p>
@@ -868,7 +879,7 @@
           <a:p>
             <a:fld id="{B31D952E-9AEA-B24E-B6B1-F2B5D1DED824}" type="datetimeFigureOut">
               <a:rPr lang="fr-FR" smtClean="0"/>
-              <a:t>08/12/2023</a:t>
+              <a:t>21/12/2023</a:t>
             </a:fld>
             <a:endParaRPr lang="fr-FR"/>
           </a:p>
@@ -1143,7 +1154,7 @@
           <a:p>
             <a:fld id="{B31D952E-9AEA-B24E-B6B1-F2B5D1DED824}" type="datetimeFigureOut">
               <a:rPr lang="fr-FR" smtClean="0"/>
-              <a:t>08/12/2023</a:t>
+              <a:t>21/12/2023</a:t>
             </a:fld>
             <a:endParaRPr lang="fr-FR"/>
           </a:p>
@@ -1408,7 +1419,7 @@
           <a:p>
             <a:fld id="{B31D952E-9AEA-B24E-B6B1-F2B5D1DED824}" type="datetimeFigureOut">
               <a:rPr lang="fr-FR" smtClean="0"/>
-              <a:t>08/12/2023</a:t>
+              <a:t>21/12/2023</a:t>
             </a:fld>
             <a:endParaRPr lang="fr-FR"/>
           </a:p>
@@ -1820,7 +1831,7 @@
           <a:p>
             <a:fld id="{B31D952E-9AEA-B24E-B6B1-F2B5D1DED824}" type="datetimeFigureOut">
               <a:rPr lang="fr-FR" smtClean="0"/>
-              <a:t>08/12/2023</a:t>
+              <a:t>21/12/2023</a:t>
             </a:fld>
             <a:endParaRPr lang="fr-FR"/>
           </a:p>
@@ -1961,7 +1972,7 @@
           <a:p>
             <a:fld id="{B31D952E-9AEA-B24E-B6B1-F2B5D1DED824}" type="datetimeFigureOut">
               <a:rPr lang="fr-FR" smtClean="0"/>
-              <a:t>08/12/2023</a:t>
+              <a:t>21/12/2023</a:t>
             </a:fld>
             <a:endParaRPr lang="fr-FR"/>
           </a:p>
@@ -2074,7 +2085,7 @@
           <a:p>
             <a:fld id="{B31D952E-9AEA-B24E-B6B1-F2B5D1DED824}" type="datetimeFigureOut">
               <a:rPr lang="fr-FR" smtClean="0"/>
-              <a:t>08/12/2023</a:t>
+              <a:t>21/12/2023</a:t>
             </a:fld>
             <a:endParaRPr lang="fr-FR"/>
           </a:p>
@@ -2385,7 +2396,7 @@
           <a:p>
             <a:fld id="{B31D952E-9AEA-B24E-B6B1-F2B5D1DED824}" type="datetimeFigureOut">
               <a:rPr lang="fr-FR" smtClean="0"/>
-              <a:t>08/12/2023</a:t>
+              <a:t>21/12/2023</a:t>
             </a:fld>
             <a:endParaRPr lang="fr-FR"/>
           </a:p>
@@ -2673,7 +2684,7 @@
           <a:p>
             <a:fld id="{B31D952E-9AEA-B24E-B6B1-F2B5D1DED824}" type="datetimeFigureOut">
               <a:rPr lang="fr-FR" smtClean="0"/>
-              <a:t>08/12/2023</a:t>
+              <a:t>21/12/2023</a:t>
             </a:fld>
             <a:endParaRPr lang="fr-FR"/>
           </a:p>
@@ -2914,7 +2925,7 @@
           <a:p>
             <a:fld id="{B31D952E-9AEA-B24E-B6B1-F2B5D1DED824}" type="datetimeFigureOut">
               <a:rPr lang="fr-FR" smtClean="0"/>
-              <a:t>08/12/2023</a:t>
+              <a:t>21/12/2023</a:t>
             </a:fld>
             <a:endParaRPr lang="fr-FR"/>
           </a:p>
@@ -3404,6 +3415,1140 @@
 </p:sld>
 </file>
 
+<file path=ppt/slides/slide10.xml><?xml version="1.0" encoding="utf-8"?>
+<p:sld xmlns:a="http://schemas.openxmlformats.org/drawingml/2006/main" xmlns:r="http://schemas.openxmlformats.org/officeDocument/2006/relationships" xmlns:p="http://schemas.openxmlformats.org/presentationml/2006/main">
+  <p:cSld>
+    <p:spTree>
+      <p:nvGrpSpPr>
+        <p:cNvPr id="1" name=""/>
+        <p:cNvGrpSpPr/>
+        <p:nvPr/>
+      </p:nvGrpSpPr>
+      <p:grpSpPr>
+        <a:xfrm>
+          <a:off x="0" y="0"/>
+          <a:ext cx="0" cy="0"/>
+          <a:chOff x="0" y="0"/>
+          <a:chExt cx="0" cy="0"/>
+        </a:xfrm>
+      </p:grpSpPr>
+      <p:sp>
+        <p:nvSpPr>
+          <p:cNvPr id="2" name="Titre 1">
+            <a:extLst>
+              <a:ext uri="{FF2B5EF4-FFF2-40B4-BE49-F238E27FC236}">
+                <a16:creationId xmlns:a16="http://schemas.microsoft.com/office/drawing/2014/main" id="{01364583-5CBD-6AF3-6650-0CAA60A2B9D2}"/>
+              </a:ext>
+            </a:extLst>
+          </p:cNvPr>
+          <p:cNvSpPr>
+            <a:spLocks noGrp="1"/>
+          </p:cNvSpPr>
+          <p:nvPr>
+            <p:ph type="title"/>
+          </p:nvPr>
+        </p:nvSpPr>
+        <p:spPr/>
+        <p:txBody>
+          <a:bodyPr/>
+          <a:lstStyle/>
+          <a:p>
+            <a:r>
+              <a:rPr lang="fr-FR" dirty="0"/>
+              <a:t>SSR</a:t>
+            </a:r>
+          </a:p>
+        </p:txBody>
+      </p:sp>
+      <p:sp>
+        <p:nvSpPr>
+          <p:cNvPr id="3" name="Espace réservé du contenu 2">
+            <a:extLst>
+              <a:ext uri="{FF2B5EF4-FFF2-40B4-BE49-F238E27FC236}">
+                <a16:creationId xmlns:a16="http://schemas.microsoft.com/office/drawing/2014/main" id="{5DE8D6A0-0F53-FAB3-505E-C2166072784C}"/>
+              </a:ext>
+            </a:extLst>
+          </p:cNvPr>
+          <p:cNvSpPr>
+            <a:spLocks noGrp="1"/>
+          </p:cNvSpPr>
+          <p:nvPr>
+            <p:ph idx="1"/>
+          </p:nvPr>
+        </p:nvSpPr>
+        <p:spPr/>
+        <p:txBody>
+          <a:bodyPr/>
+          <a:lstStyle/>
+          <a:p>
+            <a:r>
+              <a:rPr lang="fr-FR" dirty="0" err="1"/>
+              <a:t>Hydration</a:t>
+            </a:r>
+            <a:endParaRPr lang="fr-FR" dirty="0"/>
+          </a:p>
+          <a:p>
+            <a:r>
+              <a:rPr lang="fr-FR" b="0" i="0" dirty="0" err="1">
+                <a:solidFill>
+                  <a:srgbClr val="242424"/>
+                </a:solidFill>
+                <a:effectLst/>
+                <a:latin typeface="source-code-pro"/>
+              </a:rPr>
+              <a:t>ng</a:t>
+            </a:r>
+            <a:r>
+              <a:rPr lang="fr-FR" b="0" i="0" dirty="0">
+                <a:solidFill>
+                  <a:srgbClr val="242424"/>
+                </a:solidFill>
+                <a:effectLst/>
+                <a:latin typeface="source-code-pro"/>
+              </a:rPr>
+              <a:t> </a:t>
+            </a:r>
+            <a:r>
+              <a:rPr lang="fr-FR" b="0" i="0" dirty="0" err="1">
+                <a:solidFill>
+                  <a:srgbClr val="242424"/>
+                </a:solidFill>
+                <a:effectLst/>
+                <a:latin typeface="source-code-pro"/>
+              </a:rPr>
+              <a:t>add</a:t>
+            </a:r>
+            <a:r>
+              <a:rPr lang="fr-FR" b="0" i="0" dirty="0">
+                <a:solidFill>
+                  <a:srgbClr val="242424"/>
+                </a:solidFill>
+                <a:effectLst/>
+                <a:latin typeface="source-code-pro"/>
+              </a:rPr>
+              <a:t> @</a:t>
+            </a:r>
+            <a:r>
+              <a:rPr lang="fr-FR" b="0" i="0" dirty="0" err="1">
+                <a:solidFill>
+                  <a:srgbClr val="242424"/>
+                </a:solidFill>
+                <a:effectLst/>
+                <a:latin typeface="source-code-pro"/>
+              </a:rPr>
+              <a:t>angular</a:t>
+            </a:r>
+            <a:r>
+              <a:rPr lang="fr-FR" b="0" i="0" dirty="0">
+                <a:solidFill>
+                  <a:srgbClr val="242424"/>
+                </a:solidFill>
+                <a:effectLst/>
+                <a:latin typeface="source-code-pro"/>
+              </a:rPr>
+              <a:t>/</a:t>
+            </a:r>
+            <a:r>
+              <a:rPr lang="fr-FR" b="0" i="0" dirty="0" err="1">
+                <a:solidFill>
+                  <a:srgbClr val="242424"/>
+                </a:solidFill>
+                <a:effectLst/>
+                <a:latin typeface="source-code-pro"/>
+              </a:rPr>
+              <a:t>ssr</a:t>
+            </a:r>
+            <a:endParaRPr lang="fr-FR" b="0" i="0" dirty="0">
+              <a:solidFill>
+                <a:srgbClr val="242424"/>
+              </a:solidFill>
+              <a:effectLst/>
+              <a:latin typeface="source-code-pro"/>
+            </a:endParaRPr>
+          </a:p>
+          <a:p>
+            <a:r>
+              <a:rPr lang="fr-FR" dirty="0">
+                <a:solidFill>
+                  <a:srgbClr val="242424"/>
+                </a:solidFill>
+                <a:latin typeface="source-code-pro"/>
+              </a:rPr>
+              <a:t>Nouvelles fonction dans le cycle de vie</a:t>
+            </a:r>
+          </a:p>
+          <a:p>
+            <a:pPr lvl="1"/>
+            <a:r>
+              <a:rPr lang="fr-FR" b="0" i="0" dirty="0" err="1">
+                <a:solidFill>
+                  <a:srgbClr val="242424"/>
+                </a:solidFill>
+                <a:effectLst/>
+                <a:latin typeface="source-code-pro"/>
+              </a:rPr>
+              <a:t>afterRender</a:t>
+            </a:r>
+            <a:endParaRPr lang="fr-FR" b="0" i="0" dirty="0">
+              <a:solidFill>
+                <a:srgbClr val="242424"/>
+              </a:solidFill>
+              <a:effectLst/>
+              <a:latin typeface="source-code-pro"/>
+            </a:endParaRPr>
+          </a:p>
+          <a:p>
+            <a:pPr lvl="1"/>
+            <a:r>
+              <a:rPr lang="fr-FR" b="0" i="0" dirty="0" err="1">
+                <a:solidFill>
+                  <a:srgbClr val="242424"/>
+                </a:solidFill>
+                <a:effectLst/>
+                <a:latin typeface="source-code-pro"/>
+              </a:rPr>
+              <a:t>afterNextRender</a:t>
+            </a:r>
+            <a:endParaRPr lang="fr-FR" dirty="0"/>
+          </a:p>
+        </p:txBody>
+      </p:sp>
+    </p:spTree>
+    <p:extLst>
+      <p:ext uri="{BB962C8B-B14F-4D97-AF65-F5344CB8AC3E}">
+        <p14:creationId xmlns:p14="http://schemas.microsoft.com/office/powerpoint/2010/main" val="3196019992"/>
+      </p:ext>
+    </p:extLst>
+  </p:cSld>
+  <p:clrMapOvr>
+    <a:masterClrMapping/>
+  </p:clrMapOvr>
+</p:sld>
+</file>
+
+<file path=ppt/slides/slide11.xml><?xml version="1.0" encoding="utf-8"?>
+<p:sld xmlns:a="http://schemas.openxmlformats.org/drawingml/2006/main" xmlns:r="http://schemas.openxmlformats.org/officeDocument/2006/relationships" xmlns:p="http://schemas.openxmlformats.org/presentationml/2006/main">
+  <p:cSld>
+    <p:spTree>
+      <p:nvGrpSpPr>
+        <p:cNvPr id="1" name=""/>
+        <p:cNvGrpSpPr/>
+        <p:nvPr/>
+      </p:nvGrpSpPr>
+      <p:grpSpPr>
+        <a:xfrm>
+          <a:off x="0" y="0"/>
+          <a:ext cx="0" cy="0"/>
+          <a:chOff x="0" y="0"/>
+          <a:chExt cx="0" cy="0"/>
+        </a:xfrm>
+      </p:grpSpPr>
+      <p:sp>
+        <p:nvSpPr>
+          <p:cNvPr id="2" name="Titre 1">
+            <a:extLst>
+              <a:ext uri="{FF2B5EF4-FFF2-40B4-BE49-F238E27FC236}">
+                <a16:creationId xmlns:a16="http://schemas.microsoft.com/office/drawing/2014/main" id="{3F6CB08F-1FB3-7DDA-DF87-5BA121DE7781}"/>
+              </a:ext>
+            </a:extLst>
+          </p:cNvPr>
+          <p:cNvSpPr>
+            <a:spLocks noGrp="1"/>
+          </p:cNvSpPr>
+          <p:nvPr>
+            <p:ph type="title"/>
+          </p:nvPr>
+        </p:nvSpPr>
+        <p:spPr/>
+        <p:txBody>
+          <a:bodyPr/>
+          <a:lstStyle/>
+          <a:p>
+            <a:r>
+              <a:rPr lang="fr-FR" dirty="0"/>
+              <a:t>Typage des formulaires</a:t>
+            </a:r>
+          </a:p>
+        </p:txBody>
+      </p:sp>
+      <p:sp>
+        <p:nvSpPr>
+          <p:cNvPr id="3" name="Espace réservé du contenu 2">
+            <a:extLst>
+              <a:ext uri="{FF2B5EF4-FFF2-40B4-BE49-F238E27FC236}">
+                <a16:creationId xmlns:a16="http://schemas.microsoft.com/office/drawing/2014/main" id="{B79BC8C6-D2CB-4218-C3A9-8396CDC3F0B0}"/>
+              </a:ext>
+            </a:extLst>
+          </p:cNvPr>
+          <p:cNvSpPr>
+            <a:spLocks noGrp="1"/>
+          </p:cNvSpPr>
+          <p:nvPr>
+            <p:ph idx="1"/>
+          </p:nvPr>
+        </p:nvSpPr>
+        <p:spPr/>
+        <p:txBody>
+          <a:bodyPr/>
+          <a:lstStyle/>
+          <a:p>
+            <a:endParaRPr lang="fr-FR"/>
+          </a:p>
+        </p:txBody>
+      </p:sp>
+    </p:spTree>
+    <p:extLst>
+      <p:ext uri="{BB962C8B-B14F-4D97-AF65-F5344CB8AC3E}">
+        <p14:creationId xmlns:p14="http://schemas.microsoft.com/office/powerpoint/2010/main" val="2681905475"/>
+      </p:ext>
+    </p:extLst>
+  </p:cSld>
+  <p:clrMapOvr>
+    <a:masterClrMapping/>
+  </p:clrMapOvr>
+</p:sld>
+</file>
+
+<file path=ppt/slides/slide12.xml><?xml version="1.0" encoding="utf-8"?>
+<p:sld xmlns:a="http://schemas.openxmlformats.org/drawingml/2006/main" xmlns:r="http://schemas.openxmlformats.org/officeDocument/2006/relationships" xmlns:p="http://schemas.openxmlformats.org/presentationml/2006/main">
+  <p:cSld>
+    <p:spTree>
+      <p:nvGrpSpPr>
+        <p:cNvPr id="1" name=""/>
+        <p:cNvGrpSpPr/>
+        <p:nvPr/>
+      </p:nvGrpSpPr>
+      <p:grpSpPr>
+        <a:xfrm>
+          <a:off x="0" y="0"/>
+          <a:ext cx="0" cy="0"/>
+          <a:chOff x="0" y="0"/>
+          <a:chExt cx="0" cy="0"/>
+        </a:xfrm>
+      </p:grpSpPr>
+      <p:sp>
+        <p:nvSpPr>
+          <p:cNvPr id="2" name="Titre 1">
+            <a:extLst>
+              <a:ext uri="{FF2B5EF4-FFF2-40B4-BE49-F238E27FC236}">
+                <a16:creationId xmlns:a16="http://schemas.microsoft.com/office/drawing/2014/main" id="{1A80D549-2781-3DE0-6CAC-35026AC3FCAF}"/>
+              </a:ext>
+            </a:extLst>
+          </p:cNvPr>
+          <p:cNvSpPr>
+            <a:spLocks noGrp="1"/>
+          </p:cNvSpPr>
+          <p:nvPr>
+            <p:ph type="title"/>
+          </p:nvPr>
+        </p:nvSpPr>
+        <p:spPr/>
+        <p:txBody>
+          <a:bodyPr/>
+          <a:lstStyle/>
+          <a:p>
+            <a:r>
+              <a:rPr lang="fr-FR" dirty="0" err="1"/>
+              <a:t>Signals</a:t>
+            </a:r>
+            <a:endParaRPr lang="fr-FR" dirty="0"/>
+          </a:p>
+        </p:txBody>
+      </p:sp>
+      <p:sp>
+        <p:nvSpPr>
+          <p:cNvPr id="3" name="Espace réservé du contenu 2">
+            <a:extLst>
+              <a:ext uri="{FF2B5EF4-FFF2-40B4-BE49-F238E27FC236}">
+                <a16:creationId xmlns:a16="http://schemas.microsoft.com/office/drawing/2014/main" id="{81DFC92B-939B-79A8-F857-C180111E401B}"/>
+              </a:ext>
+            </a:extLst>
+          </p:cNvPr>
+          <p:cNvSpPr>
+            <a:spLocks noGrp="1"/>
+          </p:cNvSpPr>
+          <p:nvPr>
+            <p:ph idx="1"/>
+          </p:nvPr>
+        </p:nvSpPr>
+        <p:spPr/>
+        <p:txBody>
+          <a:bodyPr/>
+          <a:lstStyle/>
+          <a:p>
+            <a:endParaRPr lang="fr-FR"/>
+          </a:p>
+        </p:txBody>
+      </p:sp>
+    </p:spTree>
+    <p:extLst>
+      <p:ext uri="{BB962C8B-B14F-4D97-AF65-F5344CB8AC3E}">
+        <p14:creationId xmlns:p14="http://schemas.microsoft.com/office/powerpoint/2010/main" val="4105868915"/>
+      </p:ext>
+    </p:extLst>
+  </p:cSld>
+  <p:clrMapOvr>
+    <a:masterClrMapping/>
+  </p:clrMapOvr>
+</p:sld>
+</file>
+
+<file path=ppt/slides/slide13.xml><?xml version="1.0" encoding="utf-8"?>
+<p:sld xmlns:a="http://schemas.openxmlformats.org/drawingml/2006/main" xmlns:r="http://schemas.openxmlformats.org/officeDocument/2006/relationships" xmlns:p="http://schemas.openxmlformats.org/presentationml/2006/main">
+  <p:cSld>
+    <p:spTree>
+      <p:nvGrpSpPr>
+        <p:cNvPr id="1" name=""/>
+        <p:cNvGrpSpPr/>
+        <p:nvPr/>
+      </p:nvGrpSpPr>
+      <p:grpSpPr>
+        <a:xfrm>
+          <a:off x="0" y="0"/>
+          <a:ext cx="0" cy="0"/>
+          <a:chOff x="0" y="0"/>
+          <a:chExt cx="0" cy="0"/>
+        </a:xfrm>
+      </p:grpSpPr>
+      <p:sp>
+        <p:nvSpPr>
+          <p:cNvPr id="2" name="Titre 1">
+            <a:extLst>
+              <a:ext uri="{FF2B5EF4-FFF2-40B4-BE49-F238E27FC236}">
+                <a16:creationId xmlns:a16="http://schemas.microsoft.com/office/drawing/2014/main" id="{8412B9BE-5A37-168F-1D3B-8E1E83F7B4BD}"/>
+              </a:ext>
+            </a:extLst>
+          </p:cNvPr>
+          <p:cNvSpPr>
+            <a:spLocks noGrp="1"/>
+          </p:cNvSpPr>
+          <p:nvPr>
+            <p:ph type="title"/>
+          </p:nvPr>
+        </p:nvSpPr>
+        <p:spPr/>
+        <p:txBody>
+          <a:bodyPr/>
+          <a:lstStyle/>
+          <a:p>
+            <a:r>
+              <a:rPr lang="fr-FR" dirty="0"/>
+              <a:t>Performances</a:t>
+            </a:r>
+          </a:p>
+        </p:txBody>
+      </p:sp>
+      <p:sp>
+        <p:nvSpPr>
+          <p:cNvPr id="3" name="Espace réservé du contenu 2">
+            <a:extLst>
+              <a:ext uri="{FF2B5EF4-FFF2-40B4-BE49-F238E27FC236}">
+                <a16:creationId xmlns:a16="http://schemas.microsoft.com/office/drawing/2014/main" id="{77E06CB7-1036-4544-8C79-CCAFC963231D}"/>
+              </a:ext>
+            </a:extLst>
+          </p:cNvPr>
+          <p:cNvSpPr>
+            <a:spLocks noGrp="1"/>
+          </p:cNvSpPr>
+          <p:nvPr>
+            <p:ph idx="1"/>
+          </p:nvPr>
+        </p:nvSpPr>
+        <p:spPr/>
+        <p:txBody>
+          <a:bodyPr/>
+          <a:lstStyle/>
+          <a:p>
+            <a:r>
+              <a:rPr lang="fr-FR" dirty="0"/>
+              <a:t>Balise image</a:t>
+            </a:r>
+          </a:p>
+          <a:p>
+            <a:r>
+              <a:rPr lang="fr-FR" dirty="0"/>
+              <a:t>@</a:t>
+            </a:r>
+            <a:r>
+              <a:rPr lang="fr-FR" dirty="0" err="1"/>
+              <a:t>defer</a:t>
+            </a:r>
+            <a:endParaRPr lang="fr-FR" dirty="0"/>
+          </a:p>
+        </p:txBody>
+      </p:sp>
+    </p:spTree>
+    <p:extLst>
+      <p:ext uri="{BB962C8B-B14F-4D97-AF65-F5344CB8AC3E}">
+        <p14:creationId xmlns:p14="http://schemas.microsoft.com/office/powerpoint/2010/main" val="3227538403"/>
+      </p:ext>
+    </p:extLst>
+  </p:cSld>
+  <p:clrMapOvr>
+    <a:masterClrMapping/>
+  </p:clrMapOvr>
+</p:sld>
+</file>
+
+<file path=ppt/slides/slide14.xml><?xml version="1.0" encoding="utf-8"?>
+<p:sld xmlns:a="http://schemas.openxmlformats.org/drawingml/2006/main" xmlns:r="http://schemas.openxmlformats.org/officeDocument/2006/relationships" xmlns:p="http://schemas.openxmlformats.org/presentationml/2006/main">
+  <p:cSld>
+    <p:spTree>
+      <p:nvGrpSpPr>
+        <p:cNvPr id="1" name=""/>
+        <p:cNvGrpSpPr/>
+        <p:nvPr/>
+      </p:nvGrpSpPr>
+      <p:grpSpPr>
+        <a:xfrm>
+          <a:off x="0" y="0"/>
+          <a:ext cx="0" cy="0"/>
+          <a:chOff x="0" y="0"/>
+          <a:chExt cx="0" cy="0"/>
+        </a:xfrm>
+      </p:grpSpPr>
+      <p:sp>
+        <p:nvSpPr>
+          <p:cNvPr id="2" name="Titre 1">
+            <a:extLst>
+              <a:ext uri="{FF2B5EF4-FFF2-40B4-BE49-F238E27FC236}">
+                <a16:creationId xmlns:a16="http://schemas.microsoft.com/office/drawing/2014/main" id="{B1ABBEA4-C3B6-DE3B-0C9A-85C738DCC4EA}"/>
+              </a:ext>
+            </a:extLst>
+          </p:cNvPr>
+          <p:cNvSpPr>
+            <a:spLocks noGrp="1"/>
+          </p:cNvSpPr>
+          <p:nvPr>
+            <p:ph type="title"/>
+          </p:nvPr>
+        </p:nvSpPr>
+        <p:spPr/>
+        <p:txBody>
+          <a:bodyPr/>
+          <a:lstStyle/>
+          <a:p>
+            <a:r>
+              <a:rPr lang="fr-FR" dirty="0"/>
+              <a:t>Animations</a:t>
+            </a:r>
+          </a:p>
+        </p:txBody>
+      </p:sp>
+      <p:sp>
+        <p:nvSpPr>
+          <p:cNvPr id="3" name="Espace réservé du contenu 2">
+            <a:extLst>
+              <a:ext uri="{FF2B5EF4-FFF2-40B4-BE49-F238E27FC236}">
+                <a16:creationId xmlns:a16="http://schemas.microsoft.com/office/drawing/2014/main" id="{38B30D71-FF35-FD97-BF04-26FB82786F02}"/>
+              </a:ext>
+            </a:extLst>
+          </p:cNvPr>
+          <p:cNvSpPr>
+            <a:spLocks noGrp="1"/>
+          </p:cNvSpPr>
+          <p:nvPr>
+            <p:ph idx="1"/>
+          </p:nvPr>
+        </p:nvSpPr>
+        <p:spPr/>
+        <p:txBody>
+          <a:bodyPr/>
+          <a:lstStyle/>
+          <a:p>
+            <a:endParaRPr lang="fr-FR" dirty="0"/>
+          </a:p>
+        </p:txBody>
+      </p:sp>
+    </p:spTree>
+    <p:extLst>
+      <p:ext uri="{BB962C8B-B14F-4D97-AF65-F5344CB8AC3E}">
+        <p14:creationId xmlns:p14="http://schemas.microsoft.com/office/powerpoint/2010/main" val="2937330399"/>
+      </p:ext>
+    </p:extLst>
+  </p:cSld>
+  <p:clrMapOvr>
+    <a:masterClrMapping/>
+  </p:clrMapOvr>
+</p:sld>
+</file>
+
+<file path=ppt/slides/slide15.xml><?xml version="1.0" encoding="utf-8"?>
+<p:sld xmlns:a="http://schemas.openxmlformats.org/drawingml/2006/main" xmlns:r="http://schemas.openxmlformats.org/officeDocument/2006/relationships" xmlns:p="http://schemas.openxmlformats.org/presentationml/2006/main">
+  <p:cSld>
+    <p:spTree>
+      <p:nvGrpSpPr>
+        <p:cNvPr id="1" name=""/>
+        <p:cNvGrpSpPr/>
+        <p:nvPr/>
+      </p:nvGrpSpPr>
+      <p:grpSpPr>
+        <a:xfrm>
+          <a:off x="0" y="0"/>
+          <a:ext cx="0" cy="0"/>
+          <a:chOff x="0" y="0"/>
+          <a:chExt cx="0" cy="0"/>
+        </a:xfrm>
+      </p:grpSpPr>
+      <p:sp>
+        <p:nvSpPr>
+          <p:cNvPr id="2" name="Titre 1">
+            <a:extLst>
+              <a:ext uri="{FF2B5EF4-FFF2-40B4-BE49-F238E27FC236}">
+                <a16:creationId xmlns:a16="http://schemas.microsoft.com/office/drawing/2014/main" id="{0C5B30E1-14C7-CC06-8626-BDA2FCC8C991}"/>
+              </a:ext>
+            </a:extLst>
+          </p:cNvPr>
+          <p:cNvSpPr>
+            <a:spLocks noGrp="1"/>
+          </p:cNvSpPr>
+          <p:nvPr>
+            <p:ph type="title"/>
+          </p:nvPr>
+        </p:nvSpPr>
+        <p:spPr/>
+        <p:txBody>
+          <a:bodyPr/>
+          <a:lstStyle/>
+          <a:p>
+            <a:r>
+              <a:rPr lang="fr-FR" dirty="0"/>
+              <a:t>Conclusion</a:t>
+            </a:r>
+          </a:p>
+        </p:txBody>
+      </p:sp>
+      <p:sp>
+        <p:nvSpPr>
+          <p:cNvPr id="3" name="Espace réservé du contenu 2">
+            <a:extLst>
+              <a:ext uri="{FF2B5EF4-FFF2-40B4-BE49-F238E27FC236}">
+                <a16:creationId xmlns:a16="http://schemas.microsoft.com/office/drawing/2014/main" id="{069A576C-EDAE-03FA-C8DF-3BC1F96A21C5}"/>
+              </a:ext>
+            </a:extLst>
+          </p:cNvPr>
+          <p:cNvSpPr>
+            <a:spLocks noGrp="1"/>
+          </p:cNvSpPr>
+          <p:nvPr>
+            <p:ph idx="1"/>
+          </p:nvPr>
+        </p:nvSpPr>
+        <p:spPr/>
+        <p:txBody>
+          <a:bodyPr/>
+          <a:lstStyle/>
+          <a:p>
+            <a:endParaRPr lang="fr-FR"/>
+          </a:p>
+        </p:txBody>
+      </p:sp>
+    </p:spTree>
+    <p:extLst>
+      <p:ext uri="{BB962C8B-B14F-4D97-AF65-F5344CB8AC3E}">
+        <p14:creationId xmlns:p14="http://schemas.microsoft.com/office/powerpoint/2010/main" val="1044443636"/>
+      </p:ext>
+    </p:extLst>
+  </p:cSld>
+  <p:clrMapOvr>
+    <a:masterClrMapping/>
+  </p:clrMapOvr>
+</p:sld>
+</file>
+
+<file path=ppt/slides/slide16.xml><?xml version="1.0" encoding="utf-8"?>
+<p:sld xmlns:a="http://schemas.openxmlformats.org/drawingml/2006/main" xmlns:r="http://schemas.openxmlformats.org/officeDocument/2006/relationships" xmlns:p="http://schemas.openxmlformats.org/presentationml/2006/main">
+  <p:cSld>
+    <p:spTree>
+      <p:nvGrpSpPr>
+        <p:cNvPr id="1" name=""/>
+        <p:cNvGrpSpPr/>
+        <p:nvPr/>
+      </p:nvGrpSpPr>
+      <p:grpSpPr>
+        <a:xfrm>
+          <a:off x="0" y="0"/>
+          <a:ext cx="0" cy="0"/>
+          <a:chOff x="0" y="0"/>
+          <a:chExt cx="0" cy="0"/>
+        </a:xfrm>
+      </p:grpSpPr>
+      <p:sp>
+        <p:nvSpPr>
+          <p:cNvPr id="2" name="Titre 1">
+            <a:extLst>
+              <a:ext uri="{FF2B5EF4-FFF2-40B4-BE49-F238E27FC236}">
+                <a16:creationId xmlns:a16="http://schemas.microsoft.com/office/drawing/2014/main" id="{C66D55BA-4ACF-870F-FBCC-7671E45D4514}"/>
+              </a:ext>
+            </a:extLst>
+          </p:cNvPr>
+          <p:cNvSpPr>
+            <a:spLocks noGrp="1"/>
+          </p:cNvSpPr>
+          <p:nvPr>
+            <p:ph type="title"/>
+          </p:nvPr>
+        </p:nvSpPr>
+        <p:spPr/>
+        <p:txBody>
+          <a:bodyPr/>
+          <a:lstStyle/>
+          <a:p>
+            <a:r>
+              <a:rPr lang="fr-FR" dirty="0"/>
+              <a:t>Merci</a:t>
+            </a:r>
+          </a:p>
+        </p:txBody>
+      </p:sp>
+      <p:sp>
+        <p:nvSpPr>
+          <p:cNvPr id="3" name="Espace réservé du contenu 2">
+            <a:extLst>
+              <a:ext uri="{FF2B5EF4-FFF2-40B4-BE49-F238E27FC236}">
+                <a16:creationId xmlns:a16="http://schemas.microsoft.com/office/drawing/2014/main" id="{A3D147D6-4438-EDA6-1F8D-2E52F505A63B}"/>
+              </a:ext>
+            </a:extLst>
+          </p:cNvPr>
+          <p:cNvSpPr>
+            <a:spLocks noGrp="1"/>
+          </p:cNvSpPr>
+          <p:nvPr>
+            <p:ph idx="1"/>
+          </p:nvPr>
+        </p:nvSpPr>
+        <p:spPr/>
+        <p:txBody>
+          <a:bodyPr/>
+          <a:lstStyle/>
+          <a:p>
+            <a:endParaRPr lang="fr-FR" dirty="0"/>
+          </a:p>
+        </p:txBody>
+      </p:sp>
+    </p:spTree>
+    <p:extLst>
+      <p:ext uri="{BB962C8B-B14F-4D97-AF65-F5344CB8AC3E}">
+        <p14:creationId xmlns:p14="http://schemas.microsoft.com/office/powerpoint/2010/main" val="2360775411"/>
+      </p:ext>
+    </p:extLst>
+  </p:cSld>
+  <p:clrMapOvr>
+    <a:masterClrMapping/>
+  </p:clrMapOvr>
+</p:sld>
+</file>
+
+<file path=ppt/slides/slide17.xml><?xml version="1.0" encoding="utf-8"?>
+<p:sld xmlns:a="http://schemas.openxmlformats.org/drawingml/2006/main" xmlns:r="http://schemas.openxmlformats.org/officeDocument/2006/relationships" xmlns:p="http://schemas.openxmlformats.org/presentationml/2006/main" show="0">
+  <p:cSld>
+    <p:spTree>
+      <p:nvGrpSpPr>
+        <p:cNvPr id="1" name=""/>
+        <p:cNvGrpSpPr/>
+        <p:nvPr/>
+      </p:nvGrpSpPr>
+      <p:grpSpPr>
+        <a:xfrm>
+          <a:off x="0" y="0"/>
+          <a:ext cx="0" cy="0"/>
+          <a:chOff x="0" y="0"/>
+          <a:chExt cx="0" cy="0"/>
+        </a:xfrm>
+      </p:grpSpPr>
+      <p:sp>
+        <p:nvSpPr>
+          <p:cNvPr id="3" name="Espace réservé du contenu 2">
+            <a:extLst>
+              <a:ext uri="{FF2B5EF4-FFF2-40B4-BE49-F238E27FC236}">
+                <a16:creationId xmlns:a16="http://schemas.microsoft.com/office/drawing/2014/main" id="{335FD0D3-7D7A-FD91-812E-C563DF3D8CDC}"/>
+              </a:ext>
+            </a:extLst>
+          </p:cNvPr>
+          <p:cNvSpPr>
+            <a:spLocks noGrp="1"/>
+          </p:cNvSpPr>
+          <p:nvPr>
+            <p:ph idx="1"/>
+          </p:nvPr>
+        </p:nvSpPr>
+        <p:spPr>
+          <a:xfrm>
+            <a:off x="838200" y="987972"/>
+            <a:ext cx="10515600" cy="5188991"/>
+          </a:xfrm>
+        </p:spPr>
+        <p:txBody>
+          <a:bodyPr>
+            <a:normAutofit fontScale="92500" lnSpcReduction="20000"/>
+          </a:bodyPr>
+          <a:lstStyle/>
+          <a:p>
+            <a:pPr algn="l">
+              <a:buFont typeface="+mj-lt"/>
+              <a:buAutoNum type="arabicPeriod"/>
+            </a:pPr>
+            <a:r>
+              <a:rPr lang="fr-FR" b="0" i="0" u="none" strike="noStrike" dirty="0">
+                <a:solidFill>
+                  <a:srgbClr val="000000"/>
+                </a:solidFill>
+                <a:effectLst/>
+                <a:latin typeface="Source Sans Pro" panose="020B0503030403020204" pitchFamily="34" charset="0"/>
+              </a:rPr>
+              <a:t>Introduction à </a:t>
+            </a:r>
+            <a:r>
+              <a:rPr lang="fr-FR" b="0" i="0" u="none" strike="noStrike" dirty="0" err="1">
+                <a:solidFill>
+                  <a:srgbClr val="000000"/>
+                </a:solidFill>
+                <a:effectLst/>
+                <a:latin typeface="Source Sans Pro" panose="020B0503030403020204" pitchFamily="34" charset="0"/>
+              </a:rPr>
+              <a:t>Angular</a:t>
+            </a:r>
+            <a:r>
+              <a:rPr lang="fr-FR" b="0" i="0" u="none" strike="noStrike" dirty="0">
+                <a:solidFill>
+                  <a:srgbClr val="000000"/>
+                </a:solidFill>
+                <a:effectLst/>
+                <a:latin typeface="Source Sans Pro" panose="020B0503030403020204" pitchFamily="34" charset="0"/>
+              </a:rPr>
+              <a:t> (Nouveau logo, documentation ...)</a:t>
+            </a:r>
+          </a:p>
+          <a:p>
+            <a:pPr algn="l">
+              <a:buFont typeface="+mj-lt"/>
+              <a:buAutoNum type="arabicPeriod"/>
+            </a:pPr>
+            <a:r>
+              <a:rPr lang="fr-FR" b="0" i="0" u="none" strike="noStrike" dirty="0">
+                <a:solidFill>
+                  <a:srgbClr val="000000"/>
+                </a:solidFill>
+                <a:effectLst/>
+                <a:latin typeface="Source Sans Pro" panose="020B0503030403020204" pitchFamily="34" charset="0"/>
+              </a:rPr>
+              <a:t>Configuration des postes avec </a:t>
+            </a:r>
+            <a:r>
+              <a:rPr lang="fr-FR" b="0" i="0" u="none" strike="noStrike" dirty="0" err="1">
+                <a:solidFill>
+                  <a:srgbClr val="000000"/>
+                </a:solidFill>
+                <a:effectLst/>
+                <a:latin typeface="Source Sans Pro" panose="020B0503030403020204" pitchFamily="34" charset="0"/>
+              </a:rPr>
+              <a:t>node</a:t>
+            </a:r>
+            <a:r>
+              <a:rPr lang="fr-FR" b="0" i="0" u="none" strike="noStrike" dirty="0">
+                <a:solidFill>
+                  <a:srgbClr val="000000"/>
+                </a:solidFill>
+                <a:effectLst/>
+                <a:latin typeface="Source Sans Pro" panose="020B0503030403020204" pitchFamily="34" charset="0"/>
+              </a:rPr>
+              <a:t> (</a:t>
+            </a:r>
+            <a:r>
+              <a:rPr lang="fr-FR" b="0" i="0" u="none" strike="noStrike" dirty="0" err="1">
+                <a:solidFill>
+                  <a:srgbClr val="000000"/>
+                </a:solidFill>
+                <a:effectLst/>
+                <a:latin typeface="Source Sans Pro" panose="020B0503030403020204" pitchFamily="34" charset="0"/>
+              </a:rPr>
+              <a:t>nvm</a:t>
+            </a:r>
+            <a:r>
+              <a:rPr lang="fr-FR" b="0" i="0" u="none" strike="noStrike" dirty="0">
+                <a:solidFill>
+                  <a:srgbClr val="000000"/>
+                </a:solidFill>
+                <a:effectLst/>
+                <a:latin typeface="Source Sans Pro" panose="020B0503030403020204" pitchFamily="34" charset="0"/>
+              </a:rPr>
+              <a:t> ou docker ...)</a:t>
+            </a:r>
+          </a:p>
+          <a:p>
+            <a:pPr algn="l">
+              <a:buFont typeface="+mj-lt"/>
+              <a:buAutoNum type="arabicPeriod"/>
+            </a:pPr>
+            <a:r>
+              <a:rPr lang="fr-FR" b="0" i="0" u="none" strike="noStrike" dirty="0">
+                <a:solidFill>
+                  <a:srgbClr val="000000"/>
+                </a:solidFill>
+                <a:effectLst/>
+                <a:latin typeface="Source Sans Pro" panose="020B0503030403020204" pitchFamily="34" charset="0"/>
+              </a:rPr>
+              <a:t>Génération d'un nouveau projet</a:t>
+            </a:r>
+          </a:p>
+          <a:p>
+            <a:pPr algn="l">
+              <a:buFont typeface="+mj-lt"/>
+              <a:buAutoNum type="arabicPeriod"/>
+            </a:pPr>
+            <a:r>
+              <a:rPr lang="fr-FR" b="0" i="0" u="none" strike="noStrike" dirty="0">
+                <a:solidFill>
+                  <a:srgbClr val="000000"/>
+                </a:solidFill>
+                <a:effectLst/>
+                <a:latin typeface="Source Sans Pro" panose="020B0503030403020204" pitchFamily="34" charset="0"/>
+              </a:rPr>
+              <a:t>Exercices autour des thèmes:</a:t>
+            </a:r>
+          </a:p>
+          <a:p>
+            <a:pPr marL="742950" lvl="1" indent="-285750" algn="l">
+              <a:buFont typeface="+mj-lt"/>
+              <a:buAutoNum type="arabicPeriod"/>
+            </a:pPr>
+            <a:r>
+              <a:rPr lang="fr-FR" b="0" i="0" u="none" strike="noStrike" dirty="0">
+                <a:solidFill>
+                  <a:srgbClr val="000000"/>
+                </a:solidFill>
+                <a:effectLst/>
+                <a:latin typeface="Source Sans Pro" panose="020B0503030403020204" pitchFamily="34" charset="0"/>
+              </a:rPr>
+              <a:t>SSR</a:t>
+            </a:r>
+          </a:p>
+          <a:p>
+            <a:pPr marL="742950" lvl="1" indent="-285750" algn="l">
+              <a:buFont typeface="+mj-lt"/>
+              <a:buAutoNum type="arabicPeriod"/>
+            </a:pPr>
+            <a:r>
+              <a:rPr lang="fr-FR" b="0" i="0" u="none" strike="noStrike" dirty="0" err="1">
+                <a:solidFill>
+                  <a:srgbClr val="000000"/>
+                </a:solidFill>
+                <a:effectLst/>
+                <a:latin typeface="Source Sans Pro" panose="020B0503030403020204" pitchFamily="34" charset="0"/>
+              </a:rPr>
+              <a:t>Signals</a:t>
+            </a:r>
+            <a:endParaRPr lang="fr-FR" b="0" i="0" u="none" strike="noStrike" dirty="0">
+              <a:solidFill>
+                <a:srgbClr val="000000"/>
+              </a:solidFill>
+              <a:effectLst/>
+              <a:latin typeface="Source Sans Pro" panose="020B0503030403020204" pitchFamily="34" charset="0"/>
+            </a:endParaRPr>
+          </a:p>
+          <a:p>
+            <a:pPr marL="742950" lvl="1" indent="-285750" algn="l">
+              <a:buFont typeface="+mj-lt"/>
+              <a:buAutoNum type="arabicPeriod"/>
+            </a:pPr>
+            <a:r>
+              <a:rPr lang="fr-FR" b="0" i="0" u="none" strike="noStrike" dirty="0">
+                <a:solidFill>
+                  <a:srgbClr val="000000"/>
+                </a:solidFill>
+                <a:effectLst/>
+                <a:latin typeface="Source Sans Pro" panose="020B0503030403020204" pitchFamily="34" charset="0"/>
+              </a:rPr>
+              <a:t>Control Flow</a:t>
+            </a:r>
+          </a:p>
+          <a:p>
+            <a:pPr marL="742950" lvl="1" indent="-285750" algn="l">
+              <a:buFont typeface="+mj-lt"/>
+              <a:buAutoNum type="arabicPeriod"/>
+            </a:pPr>
+            <a:r>
+              <a:rPr lang="fr-FR" b="0" i="0" u="none" strike="noStrike" dirty="0" err="1">
+                <a:solidFill>
+                  <a:srgbClr val="000000"/>
+                </a:solidFill>
+                <a:effectLst/>
+                <a:latin typeface="Source Sans Pro" panose="020B0503030403020204" pitchFamily="34" charset="0"/>
+              </a:rPr>
+              <a:t>EsBuild</a:t>
+            </a:r>
+            <a:r>
+              <a:rPr lang="fr-FR" b="0" i="0" u="none" strike="noStrike" dirty="0">
+                <a:solidFill>
+                  <a:srgbClr val="000000"/>
+                </a:solidFill>
+                <a:effectLst/>
+                <a:latin typeface="Source Sans Pro" panose="020B0503030403020204" pitchFamily="34" charset="0"/>
+              </a:rPr>
+              <a:t> / </a:t>
+            </a:r>
+            <a:r>
+              <a:rPr lang="fr-FR" b="0" i="0" u="none" strike="noStrike" dirty="0" err="1">
+                <a:solidFill>
+                  <a:srgbClr val="000000"/>
+                </a:solidFill>
+                <a:effectLst/>
+                <a:latin typeface="Source Sans Pro" panose="020B0503030403020204" pitchFamily="34" charset="0"/>
+              </a:rPr>
+              <a:t>Jest</a:t>
+            </a:r>
+            <a:endParaRPr lang="fr-FR" b="0" i="0" u="none" strike="noStrike" dirty="0">
+              <a:solidFill>
+                <a:srgbClr val="000000"/>
+              </a:solidFill>
+              <a:effectLst/>
+              <a:latin typeface="Source Sans Pro" panose="020B0503030403020204" pitchFamily="34" charset="0"/>
+            </a:endParaRPr>
+          </a:p>
+          <a:p>
+            <a:pPr marL="742950" lvl="1" indent="-285750" algn="l">
+              <a:buFont typeface="+mj-lt"/>
+              <a:buAutoNum type="arabicPeriod"/>
+            </a:pPr>
+            <a:r>
+              <a:rPr lang="fr-FR" b="0" i="0" u="none" strike="noStrike" dirty="0">
+                <a:solidFill>
+                  <a:srgbClr val="000000"/>
+                </a:solidFill>
+                <a:effectLst/>
+                <a:latin typeface="Source Sans Pro" panose="020B0503030403020204" pitchFamily="34" charset="0"/>
+              </a:rPr>
+              <a:t>Animations</a:t>
+            </a:r>
+          </a:p>
+          <a:p>
+            <a:pPr algn="l">
+              <a:buFont typeface="+mj-lt"/>
+              <a:buAutoNum type="arabicPeriod"/>
+            </a:pPr>
+            <a:r>
+              <a:rPr lang="fr-FR" b="0" i="0" u="none" strike="noStrike" dirty="0">
+                <a:solidFill>
+                  <a:srgbClr val="000000"/>
+                </a:solidFill>
+                <a:effectLst/>
+                <a:latin typeface="Source Sans Pro" panose="020B0503030403020204" pitchFamily="34" charset="0"/>
+              </a:rPr>
+              <a:t>Parler de la migration de projet vers la version 17</a:t>
+            </a:r>
+          </a:p>
+          <a:p>
+            <a:pPr marL="742950" lvl="1" indent="-285750" algn="l">
+              <a:buFont typeface="+mj-lt"/>
+              <a:buAutoNum type="arabicPeriod"/>
+            </a:pPr>
+            <a:r>
+              <a:rPr lang="fr-FR" b="0" i="0" u="none" strike="noStrike" dirty="0" err="1">
+                <a:solidFill>
+                  <a:srgbClr val="000000"/>
+                </a:solidFill>
+                <a:effectLst/>
+                <a:latin typeface="Source Sans Pro" panose="020B0503030403020204" pitchFamily="34" charset="0"/>
+              </a:rPr>
+              <a:t>ng</a:t>
+            </a:r>
+            <a:r>
+              <a:rPr lang="fr-FR" b="0" i="0" u="none" strike="noStrike" dirty="0">
+                <a:solidFill>
+                  <a:srgbClr val="000000"/>
+                </a:solidFill>
+                <a:effectLst/>
+                <a:latin typeface="Source Sans Pro" panose="020B0503030403020204" pitchFamily="34" charset="0"/>
+              </a:rPr>
+              <a:t> update</a:t>
+            </a:r>
+          </a:p>
+          <a:p>
+            <a:pPr marL="742950" lvl="1" indent="-285750" algn="l">
+              <a:buFont typeface="+mj-lt"/>
+              <a:buAutoNum type="arabicPeriod"/>
+            </a:pPr>
+            <a:r>
+              <a:rPr lang="fr-FR" b="0" i="0" u="none" strike="noStrike" dirty="0" err="1">
+                <a:solidFill>
+                  <a:srgbClr val="000000"/>
+                </a:solidFill>
+                <a:effectLst/>
+                <a:latin typeface="Source Sans Pro" panose="020B0503030403020204" pitchFamily="34" charset="0"/>
+              </a:rPr>
+              <a:t>schematics</a:t>
+            </a:r>
+            <a:r>
+              <a:rPr lang="fr-FR" b="0" i="0" u="none" strike="noStrike" dirty="0">
+                <a:solidFill>
+                  <a:srgbClr val="000000"/>
+                </a:solidFill>
+                <a:effectLst/>
+                <a:latin typeface="Source Sans Pro" panose="020B0503030403020204" pitchFamily="34" charset="0"/>
+              </a:rPr>
+              <a:t> control flow</a:t>
+            </a:r>
+          </a:p>
+          <a:p>
+            <a:pPr marL="742950" lvl="1" indent="-285750" algn="l">
+              <a:buFont typeface="+mj-lt"/>
+              <a:buAutoNum type="arabicPeriod"/>
+            </a:pPr>
+            <a:r>
+              <a:rPr lang="fr-FR" b="0" i="0" u="none" strike="noStrike" dirty="0" err="1">
+                <a:solidFill>
+                  <a:srgbClr val="000000"/>
+                </a:solidFill>
+                <a:effectLst/>
+                <a:latin typeface="Source Sans Pro" panose="020B0503030403020204" pitchFamily="34" charset="0"/>
+              </a:rPr>
+              <a:t>schematics</a:t>
+            </a:r>
+            <a:r>
+              <a:rPr lang="fr-FR" b="0" i="0" u="none" strike="noStrike" dirty="0">
+                <a:solidFill>
+                  <a:srgbClr val="000000"/>
+                </a:solidFill>
+                <a:effectLst/>
+                <a:latin typeface="Source Sans Pro" panose="020B0503030403020204" pitchFamily="34" charset="0"/>
+              </a:rPr>
+              <a:t> standalone</a:t>
+            </a:r>
+          </a:p>
+          <a:p>
+            <a:pPr algn="l">
+              <a:buFont typeface="+mj-lt"/>
+              <a:buAutoNum type="arabicPeriod"/>
+            </a:pPr>
+            <a:r>
+              <a:rPr lang="fr-FR" b="0" i="0" u="none" strike="noStrike" dirty="0">
+                <a:solidFill>
+                  <a:srgbClr val="000000"/>
+                </a:solidFill>
+                <a:effectLst/>
+                <a:latin typeface="Source Sans Pro" panose="020B0503030403020204" pitchFamily="34" charset="0"/>
+              </a:rPr>
+              <a:t>Conclusion</a:t>
+            </a:r>
+          </a:p>
+          <a:p>
+            <a:endParaRPr lang="fr-FR" dirty="0"/>
+          </a:p>
+        </p:txBody>
+      </p:sp>
+    </p:spTree>
+    <p:extLst>
+      <p:ext uri="{BB962C8B-B14F-4D97-AF65-F5344CB8AC3E}">
+        <p14:creationId xmlns:p14="http://schemas.microsoft.com/office/powerpoint/2010/main" val="2503610671"/>
+      </p:ext>
+    </p:extLst>
+  </p:cSld>
+  <p:clrMapOvr>
+    <a:masterClrMapping/>
+  </p:clrMapOvr>
+</p:sld>
+</file>
+
 <file path=ppt/slides/slide2.xml><?xml version="1.0" encoding="utf-8"?>
 <p:sld xmlns:a="http://schemas.openxmlformats.org/drawingml/2006/main" xmlns:r="http://schemas.openxmlformats.org/officeDocument/2006/relationships" xmlns:p="http://schemas.openxmlformats.org/presentationml/2006/main">
   <p:cSld>
@@ -3443,24 +4588,572 @@
           <a:lstStyle/>
           <a:p>
             <a:r>
-              <a:rPr lang="fr-FR" dirty="0" err="1"/>
-              <a:t>Who</a:t>
-            </a:r>
-            <a:r>
-              <a:rPr lang="fr-FR" dirty="0"/>
-              <a:t> </a:t>
-            </a:r>
-            <a:r>
-              <a:rPr lang="fr-FR" dirty="0" err="1"/>
-              <a:t>am</a:t>
-            </a:r>
-            <a:r>
-              <a:rPr lang="fr-FR" dirty="0"/>
-              <a:t> I</a:t>
-            </a:r>
-          </a:p>
-        </p:txBody>
-      </p:sp>
+              <a:rPr lang="fr-FR"/>
+              <a:t>Who am I ?</a:t>
+            </a:r>
+            <a:endParaRPr lang="fr-FR" dirty="0"/>
+          </a:p>
+        </p:txBody>
+      </p:sp>
+      <p:sp>
+        <p:nvSpPr>
+          <p:cNvPr id="4" name="ZoneTexte 3">
+            <a:extLst>
+              <a:ext uri="{FF2B5EF4-FFF2-40B4-BE49-F238E27FC236}">
+                <a16:creationId xmlns:a16="http://schemas.microsoft.com/office/drawing/2014/main" id="{D88F5F2D-B92E-E456-D2E9-F4151689826E}"/>
+              </a:ext>
+            </a:extLst>
+          </p:cNvPr>
+          <p:cNvSpPr txBox="1"/>
+          <p:nvPr/>
+        </p:nvSpPr>
+        <p:spPr>
+          <a:xfrm>
+            <a:off x="416432" y="3790421"/>
+            <a:ext cx="4756238" cy="2308324"/>
+          </a:xfrm>
+          <a:prstGeom prst="rect">
+            <a:avLst/>
+          </a:prstGeom>
+          <a:noFill/>
+        </p:spPr>
+        <p:txBody>
+          <a:bodyPr wrap="none" rtlCol="0">
+            <a:spAutoFit/>
+          </a:bodyPr>
+          <a:lstStyle/>
+          <a:p>
+            <a:r>
+              <a:rPr lang="fr-FR" b="0" dirty="0">
+                <a:solidFill>
+                  <a:srgbClr val="C9D1D9"/>
+                </a:solidFill>
+                <a:effectLst/>
+                <a:latin typeface="JetBrains Mono"/>
+              </a:rPr>
+              <a:t>{</a:t>
+            </a:r>
+          </a:p>
+          <a:p>
+            <a:r>
+              <a:rPr lang="fr-FR" b="0" dirty="0">
+                <a:solidFill>
+                  <a:srgbClr val="A5D6FF"/>
+                </a:solidFill>
+                <a:effectLst/>
+                <a:latin typeface="JetBrains Mono"/>
+              </a:rPr>
+              <a:t>"</a:t>
+            </a:r>
+            <a:r>
+              <a:rPr lang="fr-FR" b="0" dirty="0" err="1">
+                <a:solidFill>
+                  <a:srgbClr val="A5D6FF"/>
+                </a:solidFill>
+                <a:effectLst/>
+                <a:latin typeface="JetBrains Mono"/>
+              </a:rPr>
+              <a:t>name</a:t>
+            </a:r>
+            <a:r>
+              <a:rPr lang="fr-FR" b="0" dirty="0">
+                <a:solidFill>
+                  <a:srgbClr val="A5D6FF"/>
+                </a:solidFill>
+                <a:effectLst/>
+                <a:latin typeface="JetBrains Mono"/>
+              </a:rPr>
+              <a:t>"</a:t>
+            </a:r>
+            <a:r>
+              <a:rPr lang="fr-FR" b="0" dirty="0">
+                <a:solidFill>
+                  <a:srgbClr val="C9D1D9"/>
+                </a:solidFill>
+                <a:effectLst/>
+                <a:latin typeface="JetBrains Mono"/>
+              </a:rPr>
+              <a:t>: </a:t>
+            </a:r>
+            <a:r>
+              <a:rPr lang="fr-FR" b="0" dirty="0">
+                <a:solidFill>
+                  <a:srgbClr val="A5D6FF"/>
+                </a:solidFill>
+                <a:effectLst/>
+                <a:latin typeface="JetBrains Mono"/>
+              </a:rPr>
+              <a:t>"Yann-Thomas Le Moigne"</a:t>
+            </a:r>
+            <a:r>
+              <a:rPr lang="fr-FR" b="0" dirty="0">
+                <a:solidFill>
+                  <a:srgbClr val="C9D1D9"/>
+                </a:solidFill>
+                <a:effectLst/>
+                <a:latin typeface="JetBrains Mono"/>
+              </a:rPr>
+              <a:t>,</a:t>
+            </a:r>
+          </a:p>
+          <a:p>
+            <a:r>
+              <a:rPr lang="fr-FR" b="0" dirty="0">
+                <a:solidFill>
+                  <a:srgbClr val="A5D6FF"/>
+                </a:solidFill>
+                <a:effectLst/>
+                <a:latin typeface="JetBrains Mono"/>
+              </a:rPr>
+              <a:t>"</a:t>
+            </a:r>
+            <a:r>
+              <a:rPr lang="fr-FR" b="0" dirty="0" err="1">
+                <a:solidFill>
+                  <a:srgbClr val="A5D6FF"/>
+                </a:solidFill>
+                <a:effectLst/>
+                <a:latin typeface="JetBrains Mono"/>
+              </a:rPr>
+              <a:t>company</a:t>
+            </a:r>
+            <a:r>
+              <a:rPr lang="fr-FR" b="0" dirty="0">
+                <a:solidFill>
+                  <a:srgbClr val="A5D6FF"/>
+                </a:solidFill>
+                <a:effectLst/>
+                <a:latin typeface="JetBrains Mono"/>
+              </a:rPr>
+              <a:t>"</a:t>
+            </a:r>
+            <a:r>
+              <a:rPr lang="fr-FR" b="0" dirty="0">
+                <a:solidFill>
+                  <a:srgbClr val="C9D1D9"/>
+                </a:solidFill>
+                <a:effectLst/>
+                <a:latin typeface="JetBrains Mono"/>
+              </a:rPr>
+              <a:t>: [</a:t>
+            </a:r>
+            <a:r>
+              <a:rPr lang="fr-FR" b="0" dirty="0">
+                <a:solidFill>
+                  <a:srgbClr val="A5D6FF"/>
+                </a:solidFill>
+                <a:effectLst/>
+                <a:latin typeface="JetBrains Mono"/>
+              </a:rPr>
+              <a:t>"Apside Top"</a:t>
+            </a:r>
+            <a:r>
+              <a:rPr lang="fr-FR" b="0" dirty="0">
+                <a:solidFill>
+                  <a:srgbClr val="C9D1D9"/>
+                </a:solidFill>
+                <a:effectLst/>
+                <a:latin typeface="JetBrains Mono"/>
+              </a:rPr>
+              <a:t>, </a:t>
+            </a:r>
+            <a:r>
+              <a:rPr lang="fr-FR" b="0" dirty="0">
+                <a:solidFill>
+                  <a:srgbClr val="A5D6FF"/>
+                </a:solidFill>
+                <a:effectLst/>
+                <a:latin typeface="JetBrains Mono"/>
+              </a:rPr>
+              <a:t>"SDIS37"</a:t>
+            </a:r>
+            <a:r>
+              <a:rPr lang="fr-FR" b="0" dirty="0">
+                <a:solidFill>
+                  <a:srgbClr val="C9D1D9"/>
+                </a:solidFill>
+                <a:effectLst/>
+                <a:latin typeface="JetBrains Mono"/>
+              </a:rPr>
+              <a:t>],</a:t>
+            </a:r>
+          </a:p>
+          <a:p>
+            <a:r>
+              <a:rPr lang="fr-FR" b="0" dirty="0">
+                <a:solidFill>
+                  <a:srgbClr val="A5D6FF"/>
+                </a:solidFill>
+                <a:effectLst/>
+                <a:latin typeface="JetBrains Mono"/>
+              </a:rPr>
+              <a:t>"job"</a:t>
+            </a:r>
+            <a:r>
+              <a:rPr lang="fr-FR" b="0" dirty="0">
+                <a:solidFill>
+                  <a:srgbClr val="C9D1D9"/>
+                </a:solidFill>
+                <a:effectLst/>
+                <a:latin typeface="JetBrains Mono"/>
+              </a:rPr>
+              <a:t>: [</a:t>
+            </a:r>
+            <a:r>
+              <a:rPr lang="fr-FR" b="0" dirty="0">
+                <a:solidFill>
+                  <a:srgbClr val="A5D6FF"/>
+                </a:solidFill>
+                <a:effectLst/>
+                <a:latin typeface="JetBrains Mono"/>
+              </a:rPr>
+              <a:t>"Tech Lead"</a:t>
+            </a:r>
+            <a:r>
+              <a:rPr lang="fr-FR" b="0" dirty="0">
+                <a:solidFill>
+                  <a:srgbClr val="C9D1D9"/>
+                </a:solidFill>
+                <a:effectLst/>
+                <a:latin typeface="JetBrains Mono"/>
+              </a:rPr>
+              <a:t>, </a:t>
+            </a:r>
+            <a:r>
+              <a:rPr lang="fr-FR" b="0" dirty="0">
+                <a:solidFill>
+                  <a:srgbClr val="A5D6FF"/>
+                </a:solidFill>
+                <a:effectLst/>
+                <a:latin typeface="JetBrains Mono"/>
+              </a:rPr>
+              <a:t>"SPV"</a:t>
+            </a:r>
+            <a:r>
+              <a:rPr lang="fr-FR" b="0" dirty="0">
+                <a:solidFill>
+                  <a:srgbClr val="C9D1D9"/>
+                </a:solidFill>
+                <a:effectLst/>
+                <a:latin typeface="JetBrains Mono"/>
+              </a:rPr>
+              <a:t>],</a:t>
+            </a:r>
+          </a:p>
+          <a:p>
+            <a:r>
+              <a:rPr lang="fr-FR" b="0" dirty="0">
+                <a:solidFill>
+                  <a:srgbClr val="A5D6FF"/>
+                </a:solidFill>
+                <a:effectLst/>
+                <a:latin typeface="JetBrains Mono"/>
+              </a:rPr>
+              <a:t>"location"</a:t>
+            </a:r>
+            <a:r>
+              <a:rPr lang="fr-FR" b="0" dirty="0">
+                <a:solidFill>
+                  <a:srgbClr val="C9D1D9"/>
+                </a:solidFill>
+                <a:effectLst/>
+                <a:latin typeface="JetBrains Mono"/>
+              </a:rPr>
+              <a:t>: </a:t>
+            </a:r>
+            <a:r>
+              <a:rPr lang="fr-FR" b="0" dirty="0">
+                <a:solidFill>
+                  <a:srgbClr val="A5D6FF"/>
+                </a:solidFill>
+                <a:effectLst/>
+                <a:latin typeface="JetBrains Mono"/>
+              </a:rPr>
+              <a:t>"Tours"</a:t>
+            </a:r>
+            <a:r>
+              <a:rPr lang="fr-FR" b="0" dirty="0">
+                <a:solidFill>
+                  <a:srgbClr val="C9D1D9"/>
+                </a:solidFill>
+                <a:effectLst/>
+                <a:latin typeface="JetBrains Mono"/>
+              </a:rPr>
+              <a:t>,</a:t>
+            </a:r>
+          </a:p>
+          <a:p>
+            <a:r>
+              <a:rPr lang="fr-FR" b="0" dirty="0">
+                <a:solidFill>
+                  <a:srgbClr val="A5D6FF"/>
+                </a:solidFill>
+                <a:effectLst/>
+                <a:latin typeface="JetBrains Mono"/>
+              </a:rPr>
+              <a:t>"</a:t>
+            </a:r>
+            <a:r>
+              <a:rPr lang="fr-FR" b="0" dirty="0" err="1">
+                <a:solidFill>
+                  <a:srgbClr val="A5D6FF"/>
+                </a:solidFill>
+                <a:effectLst/>
+                <a:latin typeface="JetBrains Mono"/>
+              </a:rPr>
+              <a:t>github</a:t>
+            </a:r>
+            <a:r>
+              <a:rPr lang="fr-FR" b="0" dirty="0">
+                <a:solidFill>
+                  <a:srgbClr val="A5D6FF"/>
+                </a:solidFill>
+                <a:effectLst/>
+                <a:latin typeface="JetBrains Mono"/>
+              </a:rPr>
+              <a:t>"</a:t>
+            </a:r>
+            <a:r>
+              <a:rPr lang="fr-FR" b="0" dirty="0">
+                <a:solidFill>
+                  <a:srgbClr val="C9D1D9"/>
+                </a:solidFill>
+                <a:effectLst/>
+                <a:latin typeface="JetBrains Mono"/>
+              </a:rPr>
+              <a:t>: </a:t>
+            </a:r>
+            <a:r>
+              <a:rPr lang="fr-FR" b="0" dirty="0">
+                <a:solidFill>
+                  <a:srgbClr val="A5D6FF"/>
+                </a:solidFill>
+                <a:effectLst/>
+                <a:latin typeface="JetBrains Mono"/>
+              </a:rPr>
+              <a:t>"</a:t>
+            </a:r>
+            <a:r>
+              <a:rPr lang="fr-FR" b="0" dirty="0" err="1">
+                <a:solidFill>
+                  <a:srgbClr val="A5D6FF"/>
+                </a:solidFill>
+                <a:effectLst/>
+                <a:latin typeface="JetBrains Mono"/>
+              </a:rPr>
+              <a:t>yatho</a:t>
+            </a:r>
+            <a:r>
+              <a:rPr lang="fr-FR" b="0" dirty="0">
+                <a:solidFill>
+                  <a:srgbClr val="A5D6FF"/>
+                </a:solidFill>
+                <a:effectLst/>
+                <a:latin typeface="JetBrains Mono"/>
+              </a:rPr>
+              <a:t>"</a:t>
+            </a:r>
+            <a:r>
+              <a:rPr lang="fr-FR" b="0" dirty="0">
+                <a:solidFill>
+                  <a:srgbClr val="C9D1D9"/>
+                </a:solidFill>
+                <a:effectLst/>
+                <a:latin typeface="JetBrains Mono"/>
+              </a:rPr>
+              <a:t>,</a:t>
+            </a:r>
+          </a:p>
+          <a:p>
+            <a:r>
+              <a:rPr lang="fr-FR" b="0" dirty="0">
+                <a:solidFill>
+                  <a:srgbClr val="A5D6FF"/>
+                </a:solidFill>
+                <a:effectLst/>
+                <a:latin typeface="JetBrains Mono"/>
+              </a:rPr>
+              <a:t>"</a:t>
+            </a:r>
+            <a:r>
+              <a:rPr lang="fr-FR" b="0" dirty="0" err="1">
+                <a:solidFill>
+                  <a:srgbClr val="A5D6FF"/>
+                </a:solidFill>
+                <a:effectLst/>
+                <a:latin typeface="JetBrains Mono"/>
+              </a:rPr>
+              <a:t>linkedIn</a:t>
+            </a:r>
+            <a:r>
+              <a:rPr lang="fr-FR" b="0" dirty="0">
+                <a:solidFill>
+                  <a:srgbClr val="A5D6FF"/>
+                </a:solidFill>
+                <a:effectLst/>
+                <a:latin typeface="JetBrains Mono"/>
+              </a:rPr>
+              <a:t>"</a:t>
+            </a:r>
+            <a:r>
+              <a:rPr lang="fr-FR" b="0" dirty="0">
+                <a:solidFill>
+                  <a:srgbClr val="C9D1D9"/>
+                </a:solidFill>
+                <a:effectLst/>
+                <a:latin typeface="JetBrains Mono"/>
+              </a:rPr>
+              <a:t>: </a:t>
+            </a:r>
+            <a:r>
+              <a:rPr lang="fr-FR" b="0" dirty="0">
+                <a:solidFill>
+                  <a:srgbClr val="A5D6FF"/>
+                </a:solidFill>
+                <a:effectLst/>
+                <a:latin typeface="JetBrains Mono"/>
+              </a:rPr>
+              <a:t>"https://</a:t>
+            </a:r>
+            <a:r>
+              <a:rPr lang="fr-FR" b="0" dirty="0" err="1">
+                <a:solidFill>
+                  <a:srgbClr val="A5D6FF"/>
+                </a:solidFill>
+                <a:effectLst/>
+                <a:latin typeface="JetBrains Mono"/>
+              </a:rPr>
+              <a:t>www.linkedin.com</a:t>
+            </a:r>
+            <a:r>
+              <a:rPr lang="fr-FR" b="0" dirty="0">
+                <a:solidFill>
+                  <a:srgbClr val="A5D6FF"/>
+                </a:solidFill>
+                <a:effectLst/>
+                <a:latin typeface="JetBrains Mono"/>
+              </a:rPr>
+              <a:t>/in/</a:t>
+            </a:r>
+            <a:r>
+              <a:rPr lang="fr-FR" b="0" dirty="0" err="1">
+                <a:solidFill>
+                  <a:srgbClr val="A5D6FF"/>
+                </a:solidFill>
+                <a:effectLst/>
+                <a:latin typeface="JetBrains Mono"/>
+              </a:rPr>
+              <a:t>yatho</a:t>
+            </a:r>
+            <a:r>
+              <a:rPr lang="fr-FR" b="0" dirty="0">
+                <a:solidFill>
+                  <a:srgbClr val="A5D6FF"/>
+                </a:solidFill>
+                <a:effectLst/>
+                <a:latin typeface="JetBrains Mono"/>
+              </a:rPr>
+              <a:t>"</a:t>
+            </a:r>
+            <a:endParaRPr lang="fr-FR" b="0" dirty="0">
+              <a:solidFill>
+                <a:srgbClr val="C9D1D9"/>
+              </a:solidFill>
+              <a:effectLst/>
+              <a:latin typeface="JetBrains Mono"/>
+            </a:endParaRPr>
+          </a:p>
+          <a:p>
+            <a:r>
+              <a:rPr lang="fr-FR" b="0" dirty="0">
+                <a:solidFill>
+                  <a:srgbClr val="C9D1D9"/>
+                </a:solidFill>
+                <a:effectLst/>
+                <a:latin typeface="JetBrains Mono"/>
+              </a:rPr>
+              <a:t>}</a:t>
+            </a:r>
+          </a:p>
+        </p:txBody>
+      </p:sp>
+      <p:pic>
+        <p:nvPicPr>
+          <p:cNvPr id="6" name="Image 5" descr="Une image contenant personne, habits, Visage humain, meubles&#10;&#10;Description générée automatiquement">
+            <a:extLst>
+              <a:ext uri="{FF2B5EF4-FFF2-40B4-BE49-F238E27FC236}">
+                <a16:creationId xmlns:a16="http://schemas.microsoft.com/office/drawing/2014/main" id="{33335925-6E87-3CED-BADE-8FA9AC3C0429}"/>
+              </a:ext>
+            </a:extLst>
+          </p:cNvPr>
+          <p:cNvPicPr>
+            <a:picLocks noChangeAspect="1"/>
+          </p:cNvPicPr>
+          <p:nvPr/>
+        </p:nvPicPr>
+        <p:blipFill>
+          <a:blip r:embed="rId2"/>
+          <a:stretch>
+            <a:fillRect/>
+          </a:stretch>
+        </p:blipFill>
+        <p:spPr>
+          <a:xfrm>
+            <a:off x="5334896" y="701544"/>
+            <a:ext cx="1980908" cy="1978288"/>
+          </a:xfrm>
+          <a:prstGeom prst="rect">
+            <a:avLst/>
+          </a:prstGeom>
+        </p:spPr>
+      </p:pic>
+      <p:pic>
+        <p:nvPicPr>
+          <p:cNvPr id="1026" name="Picture 2" descr="@yatho">
+            <a:extLst>
+              <a:ext uri="{FF2B5EF4-FFF2-40B4-BE49-F238E27FC236}">
+                <a16:creationId xmlns:a16="http://schemas.microsoft.com/office/drawing/2014/main" id="{442E2E23-7680-2ED3-662B-845CD962DFFF}"/>
+              </a:ext>
+            </a:extLst>
+          </p:cNvPr>
+          <p:cNvPicPr>
+            <a:picLocks noChangeAspect="1" noChangeArrowheads="1"/>
+          </p:cNvPicPr>
+          <p:nvPr/>
+        </p:nvPicPr>
+        <p:blipFill>
+          <a:blip r:embed="rId3">
+            <a:extLst>
+              <a:ext uri="{28A0092B-C50C-407E-A947-70E740481C1C}">
+                <a14:useLocalDpi xmlns:a14="http://schemas.microsoft.com/office/drawing/2010/main" val="0"/>
+              </a:ext>
+            </a:extLst>
+          </a:blip>
+          <a:srcRect/>
+          <a:stretch>
+            <a:fillRect/>
+          </a:stretch>
+        </p:blipFill>
+        <p:spPr bwMode="auto">
+          <a:xfrm>
+            <a:off x="3556000" y="889000"/>
+            <a:ext cx="1778896" cy="1778896"/>
+          </a:xfrm>
+          <a:prstGeom prst="rect">
+            <a:avLst/>
+          </a:prstGeom>
+          <a:noFill/>
+          <a:extLst>
+            <a:ext uri="{909E8E84-426E-40DD-AFC4-6F175D3DCCD1}">
+              <a14:hiddenFill xmlns:a14="http://schemas.microsoft.com/office/drawing/2010/main">
+                <a:solidFill>
+                  <a:srgbClr val="FFFFFF"/>
+                </a:solidFill>
+              </a14:hiddenFill>
+            </a:ext>
+          </a:extLst>
+        </p:spPr>
+      </p:pic>
     </p:spTree>
     <p:extLst>
       <p:ext uri="{BB962C8B-B14F-4D97-AF65-F5344CB8AC3E}">
@@ -3540,7 +5233,72 @@
           <a:bodyPr/>
           <a:lstStyle/>
           <a:p>
-            <a:endParaRPr lang="fr-FR"/>
+            <a:r>
+              <a:rPr lang="fr-FR"/>
+              <a:t>Quelques nouveautés d’Angular 17</a:t>
+            </a:r>
+          </a:p>
+          <a:p>
+            <a:r>
+              <a:rPr lang="fr-FR"/>
+              <a:t>Migrer une application</a:t>
+            </a:r>
+          </a:p>
+          <a:p>
+            <a:r>
+              <a:rPr lang="fr-FR"/>
+              <a:t>Entrons dans les détails</a:t>
+            </a:r>
+          </a:p>
+          <a:p>
+            <a:pPr lvl="1"/>
+            <a:r>
+              <a:rPr lang="fr-FR"/>
+              <a:t>Standalone</a:t>
+            </a:r>
+          </a:p>
+          <a:p>
+            <a:pPr lvl="1"/>
+            <a:r>
+              <a:rPr lang="fr-FR"/>
+              <a:t>Control flow</a:t>
+            </a:r>
+          </a:p>
+          <a:p>
+            <a:pPr lvl="1"/>
+            <a:r>
+              <a:rPr lang="fr-FR"/>
+              <a:t>SSR</a:t>
+            </a:r>
+          </a:p>
+          <a:p>
+            <a:pPr lvl="1"/>
+            <a:r>
+              <a:rPr lang="fr-FR"/>
+              <a:t>Typage de formulaires</a:t>
+            </a:r>
+          </a:p>
+          <a:p>
+            <a:pPr lvl="1"/>
+            <a:r>
+              <a:rPr lang="fr-FR"/>
+              <a:t>Signals</a:t>
+            </a:r>
+          </a:p>
+          <a:p>
+            <a:pPr lvl="1"/>
+            <a:r>
+              <a:rPr lang="fr-FR"/>
+              <a:t>Performances</a:t>
+            </a:r>
+          </a:p>
+          <a:p>
+            <a:pPr lvl="1"/>
+            <a:r>
+              <a:rPr lang="fr-FR"/>
+              <a:t>Animations</a:t>
+            </a:r>
+            <a:endParaRPr lang="fr-FR" dirty="0"/>
           </a:p>
         </p:txBody>
       </p:sp>
@@ -3635,10 +5393,206 @@
           <a:bodyPr/>
           <a:lstStyle/>
           <a:p>
-            <a:endParaRPr lang="fr-FR"/>
-          </a:p>
-        </p:txBody>
-      </p:sp>
+            <a:r>
+              <a:rPr lang="fr-FR" dirty="0"/>
+              <a:t>Logo</a:t>
+            </a:r>
+          </a:p>
+          <a:p>
+            <a:r>
+              <a:rPr lang="fr-FR" dirty="0"/>
+              <a:t>Documentation</a:t>
+            </a:r>
+          </a:p>
+          <a:p>
+            <a:r>
+              <a:rPr lang="fr-FR" dirty="0" err="1"/>
+              <a:t>playground</a:t>
+            </a:r>
+            <a:endParaRPr lang="fr-FR" dirty="0"/>
+          </a:p>
+        </p:txBody>
+      </p:sp>
+      <p:sp>
+        <p:nvSpPr>
+          <p:cNvPr id="5" name="ZoneTexte 4">
+            <a:extLst>
+              <a:ext uri="{FF2B5EF4-FFF2-40B4-BE49-F238E27FC236}">
+                <a16:creationId xmlns:a16="http://schemas.microsoft.com/office/drawing/2014/main" id="{F984D4C2-C1E7-8DC6-6F4C-D934D2FE37F1}"/>
+              </a:ext>
+            </a:extLst>
+          </p:cNvPr>
+          <p:cNvSpPr txBox="1"/>
+          <p:nvPr/>
+        </p:nvSpPr>
+        <p:spPr>
+          <a:xfrm>
+            <a:off x="4198570" y="2456230"/>
+            <a:ext cx="6094206" cy="369332"/>
+          </a:xfrm>
+          <a:prstGeom prst="rect">
+            <a:avLst/>
+          </a:prstGeom>
+          <a:noFill/>
+        </p:spPr>
+        <p:txBody>
+          <a:bodyPr wrap="square">
+            <a:spAutoFit/>
+          </a:bodyPr>
+          <a:lstStyle/>
+          <a:p>
+            <a:r>
+              <a:rPr lang="fr-FR" dirty="0"/>
+              <a:t>https://</a:t>
+            </a:r>
+            <a:r>
+              <a:rPr lang="fr-FR" dirty="0" err="1"/>
+              <a:t>angular.dev</a:t>
+            </a:r>
+            <a:r>
+              <a:rPr lang="fr-FR" dirty="0"/>
+              <a:t>/</a:t>
+            </a:r>
+          </a:p>
+        </p:txBody>
+      </p:sp>
+      <p:pic>
+        <p:nvPicPr>
+          <p:cNvPr id="2050" name="Picture 2" descr="@angular">
+            <a:extLst>
+              <a:ext uri="{FF2B5EF4-FFF2-40B4-BE49-F238E27FC236}">
+                <a16:creationId xmlns:a16="http://schemas.microsoft.com/office/drawing/2014/main" id="{29FE591C-4A6B-7A98-9C12-6A6CC840127F}"/>
+              </a:ext>
+            </a:extLst>
+          </p:cNvPr>
+          <p:cNvPicPr>
+            <a:picLocks noChangeAspect="1" noChangeArrowheads="1"/>
+          </p:cNvPicPr>
+          <p:nvPr/>
+        </p:nvPicPr>
+        <p:blipFill>
+          <a:blip r:embed="rId2">
+            <a:extLst>
+              <a:ext uri="{28A0092B-C50C-407E-A947-70E740481C1C}">
+                <a14:useLocalDpi xmlns:a14="http://schemas.microsoft.com/office/drawing/2010/main" val="0"/>
+              </a:ext>
+            </a:extLst>
+          </a:blip>
+          <a:srcRect/>
+          <a:stretch>
+            <a:fillRect/>
+          </a:stretch>
+        </p:blipFill>
+        <p:spPr bwMode="auto">
+          <a:xfrm>
+            <a:off x="8691381" y="1291251"/>
+            <a:ext cx="940743" cy="940743"/>
+          </a:xfrm>
+          <a:prstGeom prst="rect">
+            <a:avLst/>
+          </a:prstGeom>
+          <a:noFill/>
+          <a:extLst>
+            <a:ext uri="{909E8E84-426E-40DD-AFC4-6F175D3DCCD1}">
+              <a14:hiddenFill xmlns:a14="http://schemas.microsoft.com/office/drawing/2010/main">
+                <a:solidFill>
+                  <a:srgbClr val="FFFFFF"/>
+                </a:solidFill>
+              </a14:hiddenFill>
+            </a:ext>
+          </a:extLst>
+        </p:spPr>
+      </p:pic>
+      <p:sp>
+        <p:nvSpPr>
+          <p:cNvPr id="7" name="ZoneTexte 6">
+            <a:extLst>
+              <a:ext uri="{FF2B5EF4-FFF2-40B4-BE49-F238E27FC236}">
+                <a16:creationId xmlns:a16="http://schemas.microsoft.com/office/drawing/2014/main" id="{5FEE4E4D-D623-B4D4-262E-CE21F4DC6F60}"/>
+              </a:ext>
+            </a:extLst>
+          </p:cNvPr>
+          <p:cNvSpPr txBox="1"/>
+          <p:nvPr/>
+        </p:nvSpPr>
+        <p:spPr>
+          <a:xfrm>
+            <a:off x="4198570" y="2111330"/>
+            <a:ext cx="6094206" cy="369332"/>
+          </a:xfrm>
+          <a:prstGeom prst="rect">
+            <a:avLst/>
+          </a:prstGeom>
+          <a:noFill/>
+        </p:spPr>
+        <p:txBody>
+          <a:bodyPr wrap="square">
+            <a:spAutoFit/>
+          </a:bodyPr>
+          <a:lstStyle/>
+          <a:p>
+            <a:r>
+              <a:rPr lang="fr-FR" dirty="0"/>
+              <a:t>https://</a:t>
+            </a:r>
+            <a:r>
+              <a:rPr lang="fr-FR" dirty="0" err="1"/>
+              <a:t>angular.io</a:t>
+            </a:r>
+            <a:r>
+              <a:rPr lang="fr-FR" dirty="0"/>
+              <a:t>/</a:t>
+            </a:r>
+          </a:p>
+        </p:txBody>
+      </p:sp>
+      <p:pic>
+        <p:nvPicPr>
+          <p:cNvPr id="2052" name="Picture 4" descr="Angular - PRESS KIT">
+            <a:extLst>
+              <a:ext uri="{FF2B5EF4-FFF2-40B4-BE49-F238E27FC236}">
+                <a16:creationId xmlns:a16="http://schemas.microsoft.com/office/drawing/2014/main" id="{D82DC395-BEF7-28B1-6F41-11ABA44F8A89}"/>
+              </a:ext>
+            </a:extLst>
+          </p:cNvPr>
+          <p:cNvPicPr>
+            <a:picLocks noChangeAspect="1" noChangeArrowheads="1"/>
+          </p:cNvPicPr>
+          <p:nvPr/>
+        </p:nvPicPr>
+        <p:blipFill>
+          <a:blip r:embed="rId3">
+            <a:extLst>
+              <a:ext uri="{28A0092B-C50C-407E-A947-70E740481C1C}">
+                <a14:useLocalDpi xmlns:a14="http://schemas.microsoft.com/office/drawing/2010/main" val="0"/>
+              </a:ext>
+            </a:extLst>
+          </a:blip>
+          <a:srcRect/>
+          <a:stretch>
+            <a:fillRect/>
+          </a:stretch>
+        </p:blipFill>
+        <p:spPr bwMode="auto">
+          <a:xfrm>
+            <a:off x="7210910" y="1148763"/>
+            <a:ext cx="1147233" cy="1147233"/>
+          </a:xfrm>
+          <a:prstGeom prst="rect">
+            <a:avLst/>
+          </a:prstGeom>
+          <a:noFill/>
+          <a:extLst>
+            <a:ext uri="{909E8E84-426E-40DD-AFC4-6F175D3DCCD1}">
+              <a14:hiddenFill xmlns:a14="http://schemas.microsoft.com/office/drawing/2010/main">
+                <a:solidFill>
+                  <a:srgbClr val="FFFFFF"/>
+                </a:solidFill>
+              </a14:hiddenFill>
+            </a:ext>
+          </a:extLst>
+        </p:spPr>
+      </p:pic>
     </p:spTree>
     <p:extLst>
       <p:ext uri="{BB962C8B-B14F-4D97-AF65-F5344CB8AC3E}">
@@ -3674,7 +5628,7 @@
           <p:cNvPr id="2" name="Titre 1">
             <a:extLst>
               <a:ext uri="{FF2B5EF4-FFF2-40B4-BE49-F238E27FC236}">
-                <a16:creationId xmlns:a16="http://schemas.microsoft.com/office/drawing/2014/main" id="{74B1F34F-0F61-A096-BC5D-85C86613ABD0}"/>
+                <a16:creationId xmlns:a16="http://schemas.microsoft.com/office/drawing/2014/main" id="{FDA1B67A-452E-9A90-9DF6-56557710B953}"/>
               </a:ext>
             </a:extLst>
           </p:cNvPr>
@@ -3691,8 +5645,20 @@
           <a:lstStyle/>
           <a:p>
             <a:r>
+              <a:rPr lang="fr-FR" dirty="0" err="1"/>
+              <a:t>Esbuild</a:t>
+            </a:r>
+            <a:r>
               <a:rPr lang="fr-FR" dirty="0"/>
-              <a:t>Workshop</a:t>
+              <a:t> et Vite (</a:t>
+            </a:r>
+            <a:r>
+              <a:rPr lang="fr-FR" dirty="0" err="1"/>
+              <a:t>Jest</a:t>
+            </a:r>
+            <a:r>
+              <a:rPr lang="fr-FR" dirty="0"/>
+              <a:t>)</a:t>
             </a:r>
           </a:p>
         </p:txBody>
@@ -3702,7 +5668,7 @@
           <p:cNvPr id="3" name="Espace réservé du contenu 2">
             <a:extLst>
               <a:ext uri="{FF2B5EF4-FFF2-40B4-BE49-F238E27FC236}">
-                <a16:creationId xmlns:a16="http://schemas.microsoft.com/office/drawing/2014/main" id="{6C359F2B-4F38-D343-2574-CA1CE98DD7A5}"/>
+                <a16:creationId xmlns:a16="http://schemas.microsoft.com/office/drawing/2014/main" id="{1199837B-8B11-4C93-8EF5-1A76CBAB0FB4}"/>
               </a:ext>
             </a:extLst>
           </p:cNvPr>
@@ -3718,73 +5684,14 @@
           <a:bodyPr/>
           <a:lstStyle/>
           <a:p>
-            <a:pPr marL="0" indent="0">
-              <a:buNone/>
-            </a:pPr>
-            <a:r>
-              <a:rPr lang="fr-FR" b="0" u="sng" dirty="0">
-                <a:solidFill>
-                  <a:schemeClr val="accent1">
-                    <a:lumMod val="75000"/>
-                  </a:schemeClr>
-                </a:solidFill>
-                <a:effectLst/>
-                <a:latin typeface="JetBrains Mono"/>
-              </a:rPr>
-              <a:t>https://</a:t>
-            </a:r>
-            <a:r>
-              <a:rPr lang="fr-FR" b="0" u="sng" dirty="0" err="1">
-                <a:solidFill>
-                  <a:schemeClr val="accent1">
-                    <a:lumMod val="75000"/>
-                  </a:schemeClr>
-                </a:solidFill>
-                <a:effectLst/>
-                <a:latin typeface="JetBrains Mono"/>
-              </a:rPr>
-              <a:t>yatho.github.io</a:t>
-            </a:r>
-            <a:r>
-              <a:rPr lang="fr-FR" b="0" u="sng" dirty="0">
-                <a:solidFill>
-                  <a:schemeClr val="accent1">
-                    <a:lumMod val="75000"/>
-                  </a:schemeClr>
-                </a:solidFill>
-                <a:effectLst/>
-                <a:latin typeface="JetBrains Mono"/>
-              </a:rPr>
-              <a:t>/atelier-Angular17/atelier-angular-17/</a:t>
-            </a:r>
-            <a:endParaRPr lang="fr-FR" b="0" dirty="0">
-              <a:solidFill>
-                <a:schemeClr val="accent1">
-                  <a:lumMod val="75000"/>
-                </a:schemeClr>
-              </a:solidFill>
-              <a:effectLst/>
-              <a:latin typeface="JetBrains Mono"/>
-            </a:endParaRPr>
-          </a:p>
-          <a:p>
-            <a:pPr marL="0" indent="0">
-              <a:buNone/>
-            </a:pPr>
-            <a:endParaRPr lang="fr-FR" dirty="0">
-              <a:solidFill>
-                <a:schemeClr val="accent1">
-                  <a:lumMod val="75000"/>
-                </a:schemeClr>
-              </a:solidFill>
-            </a:endParaRPr>
+            <a:endParaRPr lang="fr-FR"/>
           </a:p>
         </p:txBody>
       </p:sp>
     </p:spTree>
     <p:extLst>
       <p:ext uri="{BB962C8B-B14F-4D97-AF65-F5344CB8AC3E}">
-        <p14:creationId xmlns:p14="http://schemas.microsoft.com/office/powerpoint/2010/main" val="1991082427"/>
+        <p14:creationId xmlns:p14="http://schemas.microsoft.com/office/powerpoint/2010/main" val="1917208445"/>
       </p:ext>
     </p:extLst>
   </p:cSld>
@@ -3795,7 +5702,7 @@
 </file>
 
 <file path=ppt/slides/slide6.xml><?xml version="1.0" encoding="utf-8"?>
-<p:sld xmlns:a="http://schemas.openxmlformats.org/drawingml/2006/main" xmlns:r="http://schemas.openxmlformats.org/officeDocument/2006/relationships" xmlns:p="http://schemas.openxmlformats.org/presentationml/2006/main" show="0">
+<p:sld xmlns:a="http://schemas.openxmlformats.org/drawingml/2006/main" xmlns:r="http://schemas.openxmlformats.org/officeDocument/2006/relationships" xmlns:p="http://schemas.openxmlformats.org/presentationml/2006/main">
   <p:cSld>
     <p:spTree>
       <p:nvGrpSpPr>
@@ -3813,10 +5720,38 @@
       </p:grpSpPr>
       <p:sp>
         <p:nvSpPr>
+          <p:cNvPr id="2" name="Titre 1">
+            <a:extLst>
+              <a:ext uri="{FF2B5EF4-FFF2-40B4-BE49-F238E27FC236}">
+                <a16:creationId xmlns:a16="http://schemas.microsoft.com/office/drawing/2014/main" id="{34EAED14-4338-6448-67C8-2D72557ACF47}"/>
+              </a:ext>
+            </a:extLst>
+          </p:cNvPr>
+          <p:cNvSpPr>
+            <a:spLocks noGrp="1"/>
+          </p:cNvSpPr>
+          <p:nvPr>
+            <p:ph type="title"/>
+          </p:nvPr>
+        </p:nvSpPr>
+        <p:spPr/>
+        <p:txBody>
+          <a:bodyPr/>
+          <a:lstStyle/>
+          <a:p>
+            <a:r>
+              <a:rPr lang="fr-FR" dirty="0"/>
+              <a:t>Avant de commencer la migration</a:t>
+            </a:r>
+          </a:p>
+        </p:txBody>
+      </p:sp>
+      <p:sp>
+        <p:nvSpPr>
           <p:cNvPr id="3" name="Espace réservé du contenu 2">
             <a:extLst>
               <a:ext uri="{FF2B5EF4-FFF2-40B4-BE49-F238E27FC236}">
-                <a16:creationId xmlns:a16="http://schemas.microsoft.com/office/drawing/2014/main" id="{335FD0D3-7D7A-FD91-812E-C563DF3D8CDC}"/>
+                <a16:creationId xmlns:a16="http://schemas.microsoft.com/office/drawing/2014/main" id="{F6A34C2C-7981-3531-B480-EB1F9D933829}"/>
               </a:ext>
             </a:extLst>
           </p:cNvPr>
@@ -3827,366 +5762,98 @@
             <p:ph idx="1"/>
           </p:nvPr>
         </p:nvSpPr>
-        <p:spPr>
-          <a:xfrm>
-            <a:off x="838200" y="987972"/>
-            <a:ext cx="10515600" cy="5188991"/>
-          </a:xfrm>
-        </p:spPr>
-        <p:txBody>
-          <a:bodyPr>
-            <a:normAutofit fontScale="92500" lnSpcReduction="20000"/>
-          </a:bodyPr>
-          <a:lstStyle/>
-          <a:p>
-            <a:pPr algn="l">
-              <a:buFont typeface="+mj-lt"/>
-              <a:buAutoNum type="arabicPeriod"/>
-            </a:pPr>
-            <a:r>
-              <a:rPr lang="fr-FR" b="0" i="0" u="none" strike="noStrike" dirty="0">
-                <a:solidFill>
-                  <a:srgbClr val="000000"/>
-                </a:solidFill>
-                <a:effectLst/>
-                <a:latin typeface="Source Sans Pro" panose="020B0503030403020204" pitchFamily="34" charset="0"/>
-              </a:rPr>
-              <a:t>Introduction à </a:t>
-            </a:r>
-            <a:r>
-              <a:rPr lang="fr-FR" b="0" i="0" u="none" strike="noStrike" dirty="0" err="1">
-                <a:solidFill>
-                  <a:srgbClr val="000000"/>
-                </a:solidFill>
-                <a:effectLst/>
-                <a:latin typeface="Source Sans Pro" panose="020B0503030403020204" pitchFamily="34" charset="0"/>
-              </a:rPr>
-              <a:t>Angular</a:t>
-            </a:r>
-            <a:r>
-              <a:rPr lang="fr-FR" b="0" i="0" u="none" strike="noStrike" dirty="0">
-                <a:solidFill>
-                  <a:srgbClr val="000000"/>
-                </a:solidFill>
-                <a:effectLst/>
-                <a:latin typeface="Source Sans Pro" panose="020B0503030403020204" pitchFamily="34" charset="0"/>
-              </a:rPr>
-              <a:t> (Nouveau logo, documentation ...)</a:t>
-            </a:r>
-          </a:p>
-          <a:p>
-            <a:pPr algn="l">
-              <a:buFont typeface="+mj-lt"/>
-              <a:buAutoNum type="arabicPeriod"/>
-            </a:pPr>
-            <a:r>
-              <a:rPr lang="fr-FR" b="0" i="0" u="none" strike="noStrike" dirty="0">
-                <a:solidFill>
-                  <a:srgbClr val="000000"/>
-                </a:solidFill>
-                <a:effectLst/>
-                <a:latin typeface="Source Sans Pro" panose="020B0503030403020204" pitchFamily="34" charset="0"/>
-              </a:rPr>
-              <a:t>Configuration des postes avec </a:t>
-            </a:r>
-            <a:r>
-              <a:rPr lang="fr-FR" b="0" i="0" u="none" strike="noStrike" dirty="0" err="1">
-                <a:solidFill>
-                  <a:srgbClr val="000000"/>
-                </a:solidFill>
-                <a:effectLst/>
-                <a:latin typeface="Source Sans Pro" panose="020B0503030403020204" pitchFamily="34" charset="0"/>
-              </a:rPr>
-              <a:t>node</a:t>
-            </a:r>
-            <a:r>
-              <a:rPr lang="fr-FR" b="0" i="0" u="none" strike="noStrike" dirty="0">
-                <a:solidFill>
-                  <a:srgbClr val="000000"/>
-                </a:solidFill>
-                <a:effectLst/>
-                <a:latin typeface="Source Sans Pro" panose="020B0503030403020204" pitchFamily="34" charset="0"/>
-              </a:rPr>
+        <p:spPr/>
+        <p:txBody>
+          <a:bodyPr/>
+          <a:lstStyle/>
+          <a:p>
+            <a:r>
+              <a:rPr lang="fr-FR" dirty="0" err="1"/>
+              <a:t>Transform</a:t>
+            </a:r>
+            <a:r>
+              <a:rPr lang="fr-FR" dirty="0"/>
+              <a:t>, </a:t>
+            </a:r>
+            <a:r>
+              <a:rPr lang="fr-FR" dirty="0" err="1"/>
+              <a:t>required</a:t>
+            </a:r>
+            <a:r>
+              <a:rPr lang="fr-FR" dirty="0"/>
+              <a:t> … input</a:t>
+            </a:r>
+          </a:p>
+          <a:p>
+            <a:r>
+              <a:rPr lang="fr-FR" dirty="0" err="1"/>
+              <a:t>inputBinding</a:t>
+            </a:r>
+            <a:endParaRPr lang="fr-FR" dirty="0"/>
+          </a:p>
+          <a:p>
+            <a:r>
+              <a:rPr lang="fr-FR" dirty="0"/>
+              <a:t>Community </a:t>
+            </a:r>
+            <a:r>
+              <a:rPr lang="fr-FR" dirty="0" err="1"/>
+              <a:t>schematics</a:t>
+            </a:r>
+            <a:r>
+              <a:rPr lang="fr-FR" dirty="0"/>
               <a:t> (</a:t>
             </a:r>
             <a:r>
-              <a:rPr lang="fr-FR" b="0" i="0" u="none" strike="noStrike" dirty="0" err="1">
-                <a:solidFill>
-                  <a:srgbClr val="000000"/>
-                </a:solidFill>
-                <a:effectLst/>
-                <a:latin typeface="Source Sans Pro" panose="020B0503030403020204" pitchFamily="34" charset="0"/>
-              </a:rPr>
-              <a:t>nvm</a:t>
-            </a:r>
-            <a:r>
-              <a:rPr lang="fr-FR" b="0" i="0" u="none" strike="noStrike" dirty="0">
-                <a:solidFill>
-                  <a:srgbClr val="000000"/>
-                </a:solidFill>
-                <a:effectLst/>
-                <a:latin typeface="Source Sans Pro" panose="020B0503030403020204" pitchFamily="34" charset="0"/>
-              </a:rPr>
-              <a:t> ou docker ...)</a:t>
-            </a:r>
-          </a:p>
-          <a:p>
-            <a:pPr algn="l">
-              <a:buFont typeface="+mj-lt"/>
-              <a:buAutoNum type="arabicPeriod"/>
-            </a:pPr>
-            <a:r>
-              <a:rPr lang="fr-FR" b="0" i="0" u="none" strike="noStrike" dirty="0">
-                <a:solidFill>
-                  <a:srgbClr val="000000"/>
-                </a:solidFill>
-                <a:effectLst/>
-                <a:latin typeface="Source Sans Pro" panose="020B0503030403020204" pitchFamily="34" charset="0"/>
-              </a:rPr>
-              <a:t>Génération d'un nouveau projet</a:t>
-            </a:r>
-          </a:p>
-          <a:p>
-            <a:pPr algn="l">
-              <a:buFont typeface="+mj-lt"/>
-              <a:buAutoNum type="arabicPeriod"/>
-            </a:pPr>
-            <a:r>
-              <a:rPr lang="fr-FR" b="0" i="0" u="none" strike="noStrike" dirty="0">
-                <a:solidFill>
-                  <a:srgbClr val="000000"/>
-                </a:solidFill>
-                <a:effectLst/>
-                <a:latin typeface="Source Sans Pro" panose="020B0503030403020204" pitchFamily="34" charset="0"/>
-              </a:rPr>
-              <a:t>Exercices autour des thèmes:</a:t>
-            </a:r>
-          </a:p>
-          <a:p>
-            <a:pPr marL="742950" lvl="1" indent="-285750" algn="l">
-              <a:buFont typeface="+mj-lt"/>
-              <a:buAutoNum type="arabicPeriod"/>
-            </a:pPr>
-            <a:r>
-              <a:rPr lang="fr-FR" b="0" i="0" u="none" strike="noStrike" dirty="0">
-                <a:solidFill>
-                  <a:srgbClr val="000000"/>
-                </a:solidFill>
-                <a:effectLst/>
-                <a:latin typeface="Source Sans Pro" panose="020B0503030403020204" pitchFamily="34" charset="0"/>
-              </a:rPr>
-              <a:t>SSR</a:t>
-            </a:r>
-          </a:p>
-          <a:p>
-            <a:pPr marL="742950" lvl="1" indent="-285750" algn="l">
-              <a:buFont typeface="+mj-lt"/>
-              <a:buAutoNum type="arabicPeriod"/>
-            </a:pPr>
-            <a:r>
-              <a:rPr lang="fr-FR" b="0" i="0" u="none" strike="noStrike" dirty="0" err="1">
-                <a:solidFill>
-                  <a:srgbClr val="000000"/>
-                </a:solidFill>
-                <a:effectLst/>
-                <a:latin typeface="Source Sans Pro" panose="020B0503030403020204" pitchFamily="34" charset="0"/>
-              </a:rPr>
-              <a:t>Signals</a:t>
-            </a:r>
-            <a:endParaRPr lang="fr-FR" b="0" i="0" u="none" strike="noStrike" dirty="0">
-              <a:solidFill>
-                <a:srgbClr val="000000"/>
-              </a:solidFill>
-              <a:effectLst/>
-              <a:latin typeface="Source Sans Pro" panose="020B0503030403020204" pitchFamily="34" charset="0"/>
-            </a:endParaRPr>
-          </a:p>
-          <a:p>
-            <a:pPr marL="742950" lvl="1" indent="-285750" algn="l">
-              <a:buFont typeface="+mj-lt"/>
-              <a:buAutoNum type="arabicPeriod"/>
-            </a:pPr>
-            <a:r>
-              <a:rPr lang="fr-FR" b="0" i="0" u="none" strike="noStrike" dirty="0">
-                <a:solidFill>
-                  <a:srgbClr val="000000"/>
-                </a:solidFill>
-                <a:effectLst/>
-                <a:latin typeface="Source Sans Pro" panose="020B0503030403020204" pitchFamily="34" charset="0"/>
-              </a:rPr>
-              <a:t>Control Flow</a:t>
-            </a:r>
-          </a:p>
-          <a:p>
-            <a:pPr marL="742950" lvl="1" indent="-285750" algn="l">
-              <a:buFont typeface="+mj-lt"/>
-              <a:buAutoNum type="arabicPeriod"/>
-            </a:pPr>
-            <a:r>
-              <a:rPr lang="fr-FR" b="0" i="0" u="none" strike="noStrike" dirty="0" err="1">
-                <a:solidFill>
-                  <a:srgbClr val="000000"/>
-                </a:solidFill>
-                <a:effectLst/>
-                <a:latin typeface="Source Sans Pro" panose="020B0503030403020204" pitchFamily="34" charset="0"/>
-              </a:rPr>
-              <a:t>EsBuild</a:t>
-            </a:r>
-            <a:r>
-              <a:rPr lang="fr-FR" b="0" i="0" u="none" strike="noStrike" dirty="0">
-                <a:solidFill>
-                  <a:srgbClr val="000000"/>
-                </a:solidFill>
-                <a:effectLst/>
-                <a:latin typeface="Source Sans Pro" panose="020B0503030403020204" pitchFamily="34" charset="0"/>
-              </a:rPr>
-              <a:t> / </a:t>
-            </a:r>
-            <a:r>
-              <a:rPr lang="fr-FR" b="0" i="0" u="none" strike="noStrike" dirty="0" err="1">
-                <a:solidFill>
-                  <a:srgbClr val="000000"/>
-                </a:solidFill>
-                <a:effectLst/>
-                <a:latin typeface="Source Sans Pro" panose="020B0503030403020204" pitchFamily="34" charset="0"/>
-              </a:rPr>
-              <a:t>Jest</a:t>
-            </a:r>
-            <a:endParaRPr lang="fr-FR" b="0" i="0" u="none" strike="noStrike" dirty="0">
-              <a:solidFill>
-                <a:srgbClr val="000000"/>
-              </a:solidFill>
-              <a:effectLst/>
-              <a:latin typeface="Source Sans Pro" panose="020B0503030403020204" pitchFamily="34" charset="0"/>
-            </a:endParaRPr>
-          </a:p>
-          <a:p>
-            <a:pPr marL="742950" lvl="1" indent="-285750" algn="l">
-              <a:buFont typeface="+mj-lt"/>
-              <a:buAutoNum type="arabicPeriod"/>
-            </a:pPr>
-            <a:r>
-              <a:rPr lang="fr-FR" b="0" i="0" u="none" strike="noStrike" dirty="0">
-                <a:solidFill>
-                  <a:srgbClr val="000000"/>
-                </a:solidFill>
-                <a:effectLst/>
-                <a:latin typeface="Source Sans Pro" panose="020B0503030403020204" pitchFamily="34" charset="0"/>
-              </a:rPr>
-              <a:t>Animations</a:t>
-            </a:r>
-          </a:p>
-          <a:p>
-            <a:pPr algn="l">
-              <a:buFont typeface="+mj-lt"/>
-              <a:buAutoNum type="arabicPeriod"/>
-            </a:pPr>
-            <a:r>
-              <a:rPr lang="fr-FR" b="0" i="0" u="none" strike="noStrike" dirty="0">
-                <a:solidFill>
-                  <a:srgbClr val="000000"/>
-                </a:solidFill>
-                <a:effectLst/>
-                <a:latin typeface="Source Sans Pro" panose="020B0503030403020204" pitchFamily="34" charset="0"/>
-              </a:rPr>
-              <a:t>Parler de la migration de projet vers la version 17</a:t>
-            </a:r>
-          </a:p>
-          <a:p>
-            <a:pPr marL="742950" lvl="1" indent="-285750" algn="l">
-              <a:buFont typeface="+mj-lt"/>
-              <a:buAutoNum type="arabicPeriod"/>
-            </a:pPr>
-            <a:r>
-              <a:rPr lang="fr-FR" b="0" i="0" u="none" strike="noStrike" dirty="0" err="1">
-                <a:solidFill>
-                  <a:srgbClr val="000000"/>
-                </a:solidFill>
-                <a:effectLst/>
-                <a:latin typeface="Source Sans Pro" panose="020B0503030403020204" pitchFamily="34" charset="0"/>
-              </a:rPr>
-              <a:t>ng</a:t>
-            </a:r>
-            <a:r>
-              <a:rPr lang="fr-FR" b="0" i="0" u="none" strike="noStrike" dirty="0">
-                <a:solidFill>
-                  <a:srgbClr val="000000"/>
-                </a:solidFill>
-                <a:effectLst/>
-                <a:latin typeface="Source Sans Pro" panose="020B0503030403020204" pitchFamily="34" charset="0"/>
-              </a:rPr>
-              <a:t> update</a:t>
-            </a:r>
-          </a:p>
-          <a:p>
-            <a:pPr marL="742950" lvl="1" indent="-285750" algn="l">
-              <a:buFont typeface="+mj-lt"/>
-              <a:buAutoNum type="arabicPeriod"/>
-            </a:pPr>
-            <a:r>
-              <a:rPr lang="fr-FR" b="0" i="0" u="none" strike="noStrike" dirty="0" err="1">
-                <a:solidFill>
-                  <a:srgbClr val="000000"/>
-                </a:solidFill>
-                <a:effectLst/>
-                <a:latin typeface="Source Sans Pro" panose="020B0503030403020204" pitchFamily="34" charset="0"/>
+              <a:rPr lang="fr-FR" b="0" i="0" dirty="0">
+                <a:solidFill>
+                  <a:srgbClr val="242424"/>
+                </a:solidFill>
+                <a:effectLst/>
+                <a:latin typeface="source-code-pro"/>
+              </a:rPr>
+              <a:t>@</a:t>
+            </a:r>
+            <a:r>
+              <a:rPr lang="fr-FR" b="0" i="0" dirty="0" err="1">
+                <a:solidFill>
+                  <a:srgbClr val="242424"/>
+                </a:solidFill>
+                <a:effectLst/>
+                <a:latin typeface="source-code-pro"/>
               </a:rPr>
               <a:t>schematics</a:t>
             </a:r>
             <a:r>
-              <a:rPr lang="fr-FR" b="0" i="0" u="none" strike="noStrike" dirty="0">
-                <a:solidFill>
-                  <a:srgbClr val="000000"/>
-                </a:solidFill>
-                <a:effectLst/>
-                <a:latin typeface="Source Sans Pro" panose="020B0503030403020204" pitchFamily="34" charset="0"/>
-              </a:rPr>
-              <a:t> control flow</a:t>
-            </a:r>
-          </a:p>
-          <a:p>
-            <a:pPr marL="742950" lvl="1" indent="-285750" algn="l">
-              <a:buFont typeface="+mj-lt"/>
-              <a:buAutoNum type="arabicPeriod"/>
-            </a:pPr>
-            <a:r>
-              <a:rPr lang="fr-FR" b="0" i="0" u="none" strike="noStrike" dirty="0" err="1">
-                <a:solidFill>
-                  <a:srgbClr val="000000"/>
-                </a:solidFill>
-                <a:effectLst/>
-                <a:latin typeface="Source Sans Pro" panose="020B0503030403020204" pitchFamily="34" charset="0"/>
-              </a:rPr>
-              <a:t>schematics</a:t>
-            </a:r>
-            <a:r>
-              <a:rPr lang="fr-FR" b="0" i="0" u="none" strike="noStrike" dirty="0">
-                <a:solidFill>
-                  <a:srgbClr val="000000"/>
-                </a:solidFill>
-                <a:effectLst/>
-                <a:latin typeface="Source Sans Pro" panose="020B0503030403020204" pitchFamily="34" charset="0"/>
-              </a:rPr>
-              <a:t> standalone</a:t>
-            </a:r>
-          </a:p>
-          <a:p>
-            <a:pPr algn="l">
-              <a:buFont typeface="+mj-lt"/>
-              <a:buAutoNum type="arabicPeriod"/>
-            </a:pPr>
-            <a:r>
-              <a:rPr lang="fr-FR" b="0" i="0" u="none" strike="noStrike" dirty="0">
-                <a:solidFill>
-                  <a:srgbClr val="000000"/>
-                </a:solidFill>
-                <a:effectLst/>
-                <a:latin typeface="Source Sans Pro" panose="020B0503030403020204" pitchFamily="34" charset="0"/>
-              </a:rPr>
-              <a:t>Conclusion</a:t>
-            </a:r>
-          </a:p>
-          <a:p>
+              <a:rPr lang="fr-FR" b="0" i="0" dirty="0">
+                <a:solidFill>
+                  <a:srgbClr val="242424"/>
+                </a:solidFill>
+                <a:effectLst/>
+                <a:latin typeface="source-code-pro"/>
+              </a:rPr>
+              <a:t>/</a:t>
+            </a:r>
+            <a:r>
+              <a:rPr lang="fr-FR" b="0" i="0" dirty="0" err="1">
+                <a:solidFill>
+                  <a:srgbClr val="242424"/>
+                </a:solidFill>
+                <a:effectLst/>
+                <a:latin typeface="source-code-pro"/>
+              </a:rPr>
+              <a:t>angular</a:t>
+            </a:r>
+            <a:r>
+              <a:rPr lang="fr-FR" b="0" i="0" dirty="0">
+                <a:solidFill>
+                  <a:srgbClr val="242424"/>
+                </a:solidFill>
+                <a:effectLst/>
+                <a:latin typeface="source-code-pro"/>
+              </a:rPr>
+              <a:t>/utility)</a:t>
+            </a:r>
             <a:endParaRPr lang="fr-FR" dirty="0"/>
           </a:p>
         </p:txBody>
@@ -4194,7 +5861,289 @@
     </p:spTree>
     <p:extLst>
       <p:ext uri="{BB962C8B-B14F-4D97-AF65-F5344CB8AC3E}">
-        <p14:creationId xmlns:p14="http://schemas.microsoft.com/office/powerpoint/2010/main" val="2503610671"/>
+        <p14:creationId xmlns:p14="http://schemas.microsoft.com/office/powerpoint/2010/main" val="4095707093"/>
+      </p:ext>
+    </p:extLst>
+  </p:cSld>
+  <p:clrMapOvr>
+    <a:masterClrMapping/>
+  </p:clrMapOvr>
+</p:sld>
+</file>
+
+<file path=ppt/slides/slide7.xml><?xml version="1.0" encoding="utf-8"?>
+<p:sld xmlns:a="http://schemas.openxmlformats.org/drawingml/2006/main" xmlns:r="http://schemas.openxmlformats.org/officeDocument/2006/relationships" xmlns:p="http://schemas.openxmlformats.org/presentationml/2006/main">
+  <p:cSld>
+    <p:spTree>
+      <p:nvGrpSpPr>
+        <p:cNvPr id="1" name=""/>
+        <p:cNvGrpSpPr/>
+        <p:nvPr/>
+      </p:nvGrpSpPr>
+      <p:grpSpPr>
+        <a:xfrm>
+          <a:off x="0" y="0"/>
+          <a:ext cx="0" cy="0"/>
+          <a:chOff x="0" y="0"/>
+          <a:chExt cx="0" cy="0"/>
+        </a:xfrm>
+      </p:grpSpPr>
+      <p:sp>
+        <p:nvSpPr>
+          <p:cNvPr id="2" name="Titre 1">
+            <a:extLst>
+              <a:ext uri="{FF2B5EF4-FFF2-40B4-BE49-F238E27FC236}">
+                <a16:creationId xmlns:a16="http://schemas.microsoft.com/office/drawing/2014/main" id="{9156DE5C-335E-EC14-573B-135038515D37}"/>
+              </a:ext>
+            </a:extLst>
+          </p:cNvPr>
+          <p:cNvSpPr>
+            <a:spLocks noGrp="1"/>
+          </p:cNvSpPr>
+          <p:nvPr>
+            <p:ph type="title"/>
+          </p:nvPr>
+        </p:nvSpPr>
+        <p:spPr/>
+        <p:txBody>
+          <a:bodyPr/>
+          <a:lstStyle/>
+          <a:p>
+            <a:r>
+              <a:rPr lang="fr-FR" dirty="0"/>
+              <a:t>Migrer ?</a:t>
+            </a:r>
+          </a:p>
+        </p:txBody>
+      </p:sp>
+      <p:sp>
+        <p:nvSpPr>
+          <p:cNvPr id="3" name="Espace réservé du contenu 2">
+            <a:extLst>
+              <a:ext uri="{FF2B5EF4-FFF2-40B4-BE49-F238E27FC236}">
+                <a16:creationId xmlns:a16="http://schemas.microsoft.com/office/drawing/2014/main" id="{028FE118-C87D-7BBB-73D2-60F35132CACF}"/>
+              </a:ext>
+            </a:extLst>
+          </p:cNvPr>
+          <p:cNvSpPr>
+            <a:spLocks noGrp="1"/>
+          </p:cNvSpPr>
+          <p:nvPr>
+            <p:ph idx="1"/>
+          </p:nvPr>
+        </p:nvSpPr>
+        <p:spPr/>
+        <p:txBody>
+          <a:bodyPr/>
+          <a:lstStyle/>
+          <a:p>
+            <a:pPr marL="0" indent="0">
+              <a:buNone/>
+            </a:pPr>
+            <a:r>
+              <a:rPr lang="fr-FR" dirty="0"/>
+              <a:t>Tout commence par une application (</a:t>
+            </a:r>
+            <a:r>
+              <a:rPr lang="fr-FR" b="0" u="sng" dirty="0">
+                <a:solidFill>
+                  <a:schemeClr val="accent1">
+                    <a:lumMod val="75000"/>
+                  </a:schemeClr>
+                </a:solidFill>
+                <a:effectLst/>
+                <a:latin typeface="JetBrains Mono"/>
+                <a:hlinkClick r:id="rId2"/>
+              </a:rPr>
+              <a:t>https://yatho.github.io/atelier-Angular17/atelier-angular-17/</a:t>
+            </a:r>
+            <a:r>
+              <a:rPr lang="fr-FR" dirty="0"/>
+              <a:t>) + Présentation de l’application</a:t>
+            </a:r>
+          </a:p>
+          <a:p>
+            <a:r>
+              <a:rPr lang="fr-FR" dirty="0" err="1"/>
+              <a:t>Ng</a:t>
+            </a:r>
+            <a:r>
+              <a:rPr lang="fr-FR" dirty="0"/>
+              <a:t> update</a:t>
+            </a:r>
+          </a:p>
+        </p:txBody>
+      </p:sp>
+    </p:spTree>
+    <p:extLst>
+      <p:ext uri="{BB962C8B-B14F-4D97-AF65-F5344CB8AC3E}">
+        <p14:creationId xmlns:p14="http://schemas.microsoft.com/office/powerpoint/2010/main" val="2718018849"/>
+      </p:ext>
+    </p:extLst>
+  </p:cSld>
+  <p:clrMapOvr>
+    <a:masterClrMapping/>
+  </p:clrMapOvr>
+</p:sld>
+</file>
+
+<file path=ppt/slides/slide8.xml><?xml version="1.0" encoding="utf-8"?>
+<p:sld xmlns:a="http://schemas.openxmlformats.org/drawingml/2006/main" xmlns:r="http://schemas.openxmlformats.org/officeDocument/2006/relationships" xmlns:p="http://schemas.openxmlformats.org/presentationml/2006/main">
+  <p:cSld>
+    <p:spTree>
+      <p:nvGrpSpPr>
+        <p:cNvPr id="1" name=""/>
+        <p:cNvGrpSpPr/>
+        <p:nvPr/>
+      </p:nvGrpSpPr>
+      <p:grpSpPr>
+        <a:xfrm>
+          <a:off x="0" y="0"/>
+          <a:ext cx="0" cy="0"/>
+          <a:chOff x="0" y="0"/>
+          <a:chExt cx="0" cy="0"/>
+        </a:xfrm>
+      </p:grpSpPr>
+      <p:sp>
+        <p:nvSpPr>
+          <p:cNvPr id="2" name="Titre 1">
+            <a:extLst>
+              <a:ext uri="{FF2B5EF4-FFF2-40B4-BE49-F238E27FC236}">
+                <a16:creationId xmlns:a16="http://schemas.microsoft.com/office/drawing/2014/main" id="{86377CB9-21BF-3146-5458-42860972B7EE}"/>
+              </a:ext>
+            </a:extLst>
+          </p:cNvPr>
+          <p:cNvSpPr>
+            <a:spLocks noGrp="1"/>
+          </p:cNvSpPr>
+          <p:nvPr>
+            <p:ph type="title"/>
+          </p:nvPr>
+        </p:nvSpPr>
+        <p:spPr/>
+        <p:txBody>
+          <a:bodyPr/>
+          <a:lstStyle/>
+          <a:p>
+            <a:r>
+              <a:rPr lang="fr-FR" dirty="0"/>
+              <a:t>Standalone</a:t>
+            </a:r>
+          </a:p>
+        </p:txBody>
+      </p:sp>
+      <p:sp>
+        <p:nvSpPr>
+          <p:cNvPr id="3" name="Espace réservé du contenu 2">
+            <a:extLst>
+              <a:ext uri="{FF2B5EF4-FFF2-40B4-BE49-F238E27FC236}">
+                <a16:creationId xmlns:a16="http://schemas.microsoft.com/office/drawing/2014/main" id="{FD2C9F15-285F-BFEA-DA57-4CFDB9FFD9B5}"/>
+              </a:ext>
+            </a:extLst>
+          </p:cNvPr>
+          <p:cNvSpPr>
+            <a:spLocks noGrp="1"/>
+          </p:cNvSpPr>
+          <p:nvPr>
+            <p:ph idx="1"/>
+          </p:nvPr>
+        </p:nvSpPr>
+        <p:spPr/>
+        <p:txBody>
+          <a:bodyPr/>
+          <a:lstStyle/>
+          <a:p>
+            <a:endParaRPr lang="fr-FR"/>
+          </a:p>
+        </p:txBody>
+      </p:sp>
+    </p:spTree>
+    <p:extLst>
+      <p:ext uri="{BB962C8B-B14F-4D97-AF65-F5344CB8AC3E}">
+        <p14:creationId xmlns:p14="http://schemas.microsoft.com/office/powerpoint/2010/main" val="2928790376"/>
+      </p:ext>
+    </p:extLst>
+  </p:cSld>
+  <p:clrMapOvr>
+    <a:masterClrMapping/>
+  </p:clrMapOvr>
+</p:sld>
+</file>
+
+<file path=ppt/slides/slide9.xml><?xml version="1.0" encoding="utf-8"?>
+<p:sld xmlns:a="http://schemas.openxmlformats.org/drawingml/2006/main" xmlns:r="http://schemas.openxmlformats.org/officeDocument/2006/relationships" xmlns:p="http://schemas.openxmlformats.org/presentationml/2006/main">
+  <p:cSld>
+    <p:spTree>
+      <p:nvGrpSpPr>
+        <p:cNvPr id="1" name=""/>
+        <p:cNvGrpSpPr/>
+        <p:nvPr/>
+      </p:nvGrpSpPr>
+      <p:grpSpPr>
+        <a:xfrm>
+          <a:off x="0" y="0"/>
+          <a:ext cx="0" cy="0"/>
+          <a:chOff x="0" y="0"/>
+          <a:chExt cx="0" cy="0"/>
+        </a:xfrm>
+      </p:grpSpPr>
+      <p:sp>
+        <p:nvSpPr>
+          <p:cNvPr id="2" name="Titre 1">
+            <a:extLst>
+              <a:ext uri="{FF2B5EF4-FFF2-40B4-BE49-F238E27FC236}">
+                <a16:creationId xmlns:a16="http://schemas.microsoft.com/office/drawing/2014/main" id="{1F1DE2C5-8128-8316-7F8A-7B510689A4A3}"/>
+              </a:ext>
+            </a:extLst>
+          </p:cNvPr>
+          <p:cNvSpPr>
+            <a:spLocks noGrp="1"/>
+          </p:cNvSpPr>
+          <p:nvPr>
+            <p:ph type="title"/>
+          </p:nvPr>
+        </p:nvSpPr>
+        <p:spPr/>
+        <p:txBody>
+          <a:bodyPr/>
+          <a:lstStyle/>
+          <a:p>
+            <a:r>
+              <a:rPr lang="fr-FR" dirty="0"/>
+              <a:t>Control flow</a:t>
+            </a:r>
+          </a:p>
+        </p:txBody>
+      </p:sp>
+      <p:sp>
+        <p:nvSpPr>
+          <p:cNvPr id="3" name="Espace réservé du contenu 2">
+            <a:extLst>
+              <a:ext uri="{FF2B5EF4-FFF2-40B4-BE49-F238E27FC236}">
+                <a16:creationId xmlns:a16="http://schemas.microsoft.com/office/drawing/2014/main" id="{0F3B90AE-7CF1-22AA-AB10-F89CE4FCA559}"/>
+              </a:ext>
+            </a:extLst>
+          </p:cNvPr>
+          <p:cNvSpPr>
+            <a:spLocks noGrp="1"/>
+          </p:cNvSpPr>
+          <p:nvPr>
+            <p:ph idx="1"/>
+          </p:nvPr>
+        </p:nvSpPr>
+        <p:spPr/>
+        <p:txBody>
+          <a:bodyPr/>
+          <a:lstStyle/>
+          <a:p>
+            <a:endParaRPr lang="fr-FR"/>
+          </a:p>
+        </p:txBody>
+      </p:sp>
+    </p:spTree>
+    <p:extLst>
+      <p:ext uri="{BB962C8B-B14F-4D97-AF65-F5344CB8AC3E}">
+        <p14:creationId xmlns:p14="http://schemas.microsoft.com/office/powerpoint/2010/main" val="3451485198"/>
       </p:ext>
     </p:extLst>
   </p:cSld>

</xml_diff>